<commit_message>
docs: redesign PowerPoint (value, AI features, Groq architecture, stack) and update docs
</commit_message>
<xml_diff>
--- a/slides.pptx
+++ b/slides.pptx
@@ -17,9 +17,10 @@
     <p:sldId id="265" r:id="rId11"/>
     <p:sldId id="266" r:id="rId12"/>
     <p:sldId id="267" r:id="rId13"/>
+    <p:sldId id="268" r:id="rId14"/>
   </p:sldIdLst>
   <p:notesMasterIdLst>
-    <p:notesMasterId r:id="rId14"/>
+    <p:notesMasterId r:id="rId15"/>
   </p:notesMasterIdLst>
   <p:sldSz cx="12188952" cy="6858000"/>
   <p:notesSz cx="6858000" cy="12188952"/>
@@ -801,6 +802,94 @@
             <a:fld id="{F7021451-1387-4CA6-816F-3879F97B5CBC}" type="slidenum">
               <a:rPr lang="en-US"/>
               <a:t>12</a:t>
+            </a:fld>
+            <a:endParaRPr lang="en-US"/>
+          </a:p>
+        </p:txBody>
+      </p:sp>
+    </p:spTree>
+    <p:extLst>
+      <p:ext uri="{BB962C8B-B14F-4D97-AF65-F5344CB8AC3E}">
+        <p14:creationId xmlns:p14="http://schemas.microsoft.com/office/powerpoint/2010/main" val="1024086991"/>
+      </p:ext>
+    </p:extLst>
+  </p:cSld>
+  <p:clrMapOvr>
+    <a:masterClrMapping/>
+  </p:clrMapOvr>
+</p:notes>
+</file>
+
+<file path=ppt/notesSlides/notesSlide13.xml><?xml version="1.0" encoding="utf-8"?>
+<p:notes xmlns:a="http://schemas.openxmlformats.org/drawingml/2006/main" xmlns:r="http://schemas.openxmlformats.org/officeDocument/2006/relationships" xmlns:p="http://schemas.openxmlformats.org/presentationml/2006/main">
+  <p:cSld>
+    <p:spTree>
+      <p:nvGrpSpPr>
+        <p:cNvPr id="1" name=""/>
+        <p:cNvGrpSpPr/>
+        <p:nvPr/>
+      </p:nvGrpSpPr>
+      <p:grpSpPr>
+        <a:xfrm>
+          <a:off x="0" y="0"/>
+          <a:ext cx="0" cy="0"/>
+          <a:chOff x="0" y="0"/>
+          <a:chExt cx="0" cy="0"/>
+        </a:xfrm>
+      </p:grpSpPr>
+      <p:sp>
+        <p:nvSpPr>
+          <p:cNvPr id="2" name="Slide Image Placeholder 1"/>
+          <p:cNvSpPr>
+            <a:spLocks noGrp="1" noRot="1" noChangeAspect="1"/>
+          </p:cNvSpPr>
+          <p:nvPr>
+            <p:ph type="sldImg"/>
+          </p:nvPr>
+        </p:nvSpPr>
+        <p:spPr/>
+      </p:sp>
+      <p:sp>
+        <p:nvSpPr>
+          <p:cNvPr id="3" name="Notes Placeholder 2"/>
+          <p:cNvSpPr>
+            <a:spLocks noGrp="1"/>
+          </p:cNvSpPr>
+          <p:nvPr>
+            <p:ph type="body" idx="1"/>
+          </p:nvPr>
+        </p:nvSpPr>
+        <p:spPr/>
+        <p:txBody>
+          <a:bodyPr/>
+          <a:lstStyle/>
+          <a:p>
+            <a:r>
+              <a:rPr lang="en-US" dirty="0"/>
+              <a:t/>
+            </a:r>
+            <a:endParaRPr lang="en-US" dirty="0"/>
+          </a:p>
+        </p:txBody>
+      </p:sp>
+      <p:sp>
+        <p:nvSpPr>
+          <p:cNvPr id="4" name="Slide Number Placeholder 3"/>
+          <p:cNvSpPr>
+            <a:spLocks noGrp="1"/>
+          </p:cNvSpPr>
+          <p:nvPr>
+            <p:ph type="sldNum" sz="quarter" idx="10"/>
+          </p:nvPr>
+        </p:nvSpPr>
+        <p:spPr/>
+        <p:txBody>
+          <a:bodyPr/>
+          <a:lstStyle/>
+          <a:p>
+            <a:fld id="{F7021451-1387-4CA6-816F-3879F97B5CBC}" type="slidenum">
+              <a:rPr lang="en-US"/>
+              <a:t>13</a:t>
             </a:fld>
             <a:endParaRPr lang="en-US"/>
           </a:p>
@@ -1902,8 +1991,8 @@
         </p:nvSpPr>
         <p:spPr>
           <a:xfrm>
-            <a:off x="1005840" y="1371600"/>
-            <a:ext cx="1005840" cy="1005840"/>
+            <a:off x="1005840" y="1097280"/>
+            <a:ext cx="914400" cy="914400"/>
           </a:xfrm>
           <a:prstGeom prst="roundRect">
             <a:avLst>
@@ -1924,8 +2013,8 @@
         </p:nvSpPr>
         <p:spPr>
           <a:xfrm>
-            <a:off x="1005840" y="1371600"/>
-            <a:ext cx="1005840" cy="1005840"/>
+            <a:off x="1005840" y="1097280"/>
+            <a:ext cx="914400" cy="914400"/>
           </a:xfrm>
           <a:prstGeom prst="rect">
             <a:avLst/>
@@ -1941,7 +2030,7 @@
               <a:buNone/>
             </a:pPr>
             <a:r>
-              <a:rPr lang="en-US" sz="2860" b="1" dirty="0">
+              <a:rPr lang="en-US" sz="2600" b="1" dirty="0">
                 <a:solidFill>
                   <a:srgbClr val="FFFFFF"/>
                 </a:solidFill>
@@ -1951,7 +2040,7 @@
               </a:rPr>
               <a:t>RK</a:t>
             </a:r>
-            <a:endParaRPr lang="en-US" sz="2860" dirty="0"/>
+            <a:endParaRPr lang="en-US" sz="2600" dirty="0"/>
           </a:p>
         </p:txBody>
       </p:sp>
@@ -1963,8 +2052,8 @@
         </p:nvSpPr>
         <p:spPr>
           <a:xfrm>
-            <a:off x="1005840" y="2651760"/>
-            <a:ext cx="10058400" cy="1097280"/>
+            <a:off x="1005840" y="2286000"/>
+            <a:ext cx="10515600" cy="1097280"/>
           </a:xfrm>
           <a:prstGeom prst="rect">
             <a:avLst/>
@@ -2002,8 +2091,8 @@
         </p:nvSpPr>
         <p:spPr>
           <a:xfrm>
-            <a:off x="1005840" y="3749040"/>
-            <a:ext cx="10058400" cy="640080"/>
+            <a:off x="1005840" y="3429000"/>
+            <a:ext cx="10515600" cy="640080"/>
           </a:xfrm>
           <a:prstGeom prst="rect">
             <a:avLst/>
@@ -2027,7 +2116,7 @@
                 <a:ea typeface="Segoe UI" pitchFamily="34" charset="-122"/>
                 <a:cs typeface="Segoe UI" pitchFamily="34" charset="-120"/>
               </a:rPr>
-              <a:t>Herramientas para una selección más justa y eficaz</a:t>
+              <a:t>El kit de herramientas para una selección más justa y eficaz</a:t>
             </a:r>
             <a:endParaRPr lang="en-US" sz="2200" dirty="0"/>
           </a:p>
@@ -2041,7 +2130,46 @@
         </p:nvSpPr>
         <p:spPr>
           <a:xfrm>
-            <a:off x="1005840" y="4754880"/>
+            <a:off x="1005840" y="4160520"/>
+            <a:ext cx="10515600" cy="457200"/>
+          </a:xfrm>
+          <a:prstGeom prst="rect">
+            <a:avLst/>
+          </a:prstGeom>
+          <a:noFill/>
+          <a:ln/>
+        </p:spPr>
+        <p:txBody>
+          <a:bodyPr wrap="square" rtlCol="0" anchor="ctr"/>
+          <a:lstStyle/>
+          <a:p>
+            <a:pPr indent="0" marL="0">
+              <a:buNone/>
+            </a:pPr>
+            <a:r>
+              <a:rPr lang="en-US" sz="1500" dirty="0">
+                <a:solidFill>
+                  <a:srgbClr val="94A3B8"/>
+                </a:solidFill>
+                <a:latin typeface="Segoe UI" pitchFamily="34" charset="0"/>
+                <a:ea typeface="Segoe UI" pitchFamily="34" charset="-122"/>
+                <a:cs typeface="Segoe UI" pitchFamily="34" charset="-120"/>
+              </a:rPr>
+              <a:t>Analiza y redacta ofertas · Evalúa candidatos · Entrevista y comunica</a:t>
+            </a:r>
+            <a:endParaRPr lang="en-US" sz="1500" dirty="0"/>
+          </a:p>
+        </p:txBody>
+      </p:sp>
+      <p:sp>
+        <p:nvSpPr>
+          <p:cNvPr id="9" name="Text 7"/>
+          <p:cNvSpPr/>
+          <p:nvPr/>
+        </p:nvSpPr>
+        <p:spPr>
+          <a:xfrm>
+            <a:off x="1005840" y="5120640"/>
             <a:ext cx="10058400" cy="457200"/>
           </a:xfrm>
           <a:prstGeom prst="rect">
@@ -2058,9 +2186,9 @@
               <a:buNone/>
             </a:pPr>
             <a:r>
-              <a:rPr lang="en-US" sz="1600" dirty="0">
-                <a:solidFill>
-                  <a:srgbClr val="94A3B8"/>
+              <a:rPr lang="en-US" sz="1500" dirty="0">
+                <a:solidFill>
+                  <a:srgbClr val="64748B"/>
                 </a:solidFill>
                 <a:latin typeface="Segoe UI" pitchFamily="34" charset="0"/>
                 <a:ea typeface="Segoe UI" pitchFamily="34" charset="-122"/>
@@ -2068,7 +2196,7 @@
               </a:rPr>
               <a:t>Juan Ignacio Guitart   ·   TFM   ·   2026</a:t>
             </a:r>
-            <a:endParaRPr lang="en-US" sz="1600" dirty="0"/>
+            <a:endParaRPr lang="en-US" sz="1500" dirty="0"/>
           </a:p>
         </p:txBody>
       </p:sp>
@@ -2157,7 +2285,7 @@
                 <a:ea typeface="Segoe UI" pitchFamily="34" charset="-122"/>
                 <a:cs typeface="Segoe UI" pitchFamily="34" charset="-120"/>
               </a:rPr>
-              <a:t>Decisiones técnicas</a:t>
+              <a:t>Stack técnico</a:t>
             </a:r>
             <a:endParaRPr lang="en-US" sz="3000" dirty="0"/>
           </a:p>
@@ -2171,31 +2299,90 @@
         </p:nvSpPr>
         <p:spPr>
           <a:xfrm>
-            <a:off x="822960" y="1737360"/>
-            <a:ext cx="10515600" cy="4206240"/>
-          </a:xfrm>
-          <a:prstGeom prst="rect">
-            <a:avLst/>
-          </a:prstGeom>
-          <a:noFill/>
-          <a:ln/>
-        </p:spPr>
-        <p:txBody>
-          <a:bodyPr wrap="square" rtlCol="0" anchor="t"/>
-          <a:lstStyle/>
-          <a:p>
-            <a:pPr marL="228600" indent="-228600">
-              <a:lnSpc>
-                <a:spcPct val="115000"/>
-              </a:lnSpc>
-              <a:spcAft>
-                <a:spcPts val="1000"/>
-              </a:spcAft>
-              <a:buSzPct val="100000"/>
-              <a:buChar char="•"/>
-            </a:pPr>
-            <a:r>
-              <a:rPr lang="en-US" sz="1900" dirty="0">
+            <a:off x="731520" y="1737360"/>
+            <a:ext cx="1737360" cy="457200"/>
+          </a:xfrm>
+          <a:prstGeom prst="rect">
+            <a:avLst/>
+          </a:prstGeom>
+          <a:noFill/>
+          <a:ln/>
+        </p:spPr>
+        <p:txBody>
+          <a:bodyPr wrap="square" rtlCol="0" anchor="ctr"/>
+          <a:lstStyle/>
+          <a:p>
+            <a:pPr indent="0" marL="0">
+              <a:buNone/>
+            </a:pPr>
+            <a:r>
+              <a:rPr lang="en-US" sz="1500" b="1" dirty="0">
+                <a:solidFill>
+                  <a:srgbClr val="4F46E5"/>
+                </a:solidFill>
+                <a:latin typeface="Segoe UI" pitchFamily="34" charset="0"/>
+                <a:ea typeface="Segoe UI" pitchFamily="34" charset="-122"/>
+                <a:cs typeface="Segoe UI" pitchFamily="34" charset="-120"/>
+              </a:rPr>
+              <a:t>Frontend</a:t>
+            </a:r>
+            <a:endParaRPr lang="en-US" sz="1500" dirty="0"/>
+          </a:p>
+        </p:txBody>
+      </p:sp>
+      <p:sp>
+        <p:nvSpPr>
+          <p:cNvPr id="5" name="Shape 3"/>
+          <p:cNvSpPr/>
+          <p:nvPr/>
+        </p:nvSpPr>
+        <p:spPr>
+          <a:xfrm>
+            <a:off x="2651760" y="1755648"/>
+            <a:ext cx="1417320" cy="420624"/>
+          </a:xfrm>
+          <a:prstGeom prst="roundRect">
+            <a:avLst>
+              <a:gd name="adj" fmla="val 50000"/>
+            </a:avLst>
+          </a:prstGeom>
+          <a:solidFill>
+            <a:srgbClr val="F1F5F9"/>
+          </a:solidFill>
+          <a:ln w="12700">
+            <a:solidFill>
+              <a:srgbClr val="E2E8F0"/>
+            </a:solidFill>
+            <a:prstDash val="solid"/>
+          </a:ln>
+        </p:spPr>
+      </p:sp>
+      <p:sp>
+        <p:nvSpPr>
+          <p:cNvPr id="6" name="Text 4"/>
+          <p:cNvSpPr/>
+          <p:nvPr/>
+        </p:nvSpPr>
+        <p:spPr>
+          <a:xfrm>
+            <a:off x="2651760" y="1755648"/>
+            <a:ext cx="1417320" cy="420624"/>
+          </a:xfrm>
+          <a:prstGeom prst="rect">
+            <a:avLst/>
+          </a:prstGeom>
+          <a:noFill/>
+          <a:ln/>
+        </p:spPr>
+        <p:txBody>
+          <a:bodyPr wrap="square" rtlCol="0" anchor="ctr"/>
+          <a:lstStyle/>
+          <a:p>
+            <a:pPr algn="ctr" indent="0" marL="0">
+              <a:buNone/>
+            </a:pPr>
+            <a:r>
+              <a:rPr lang="en-US" sz="1250" dirty="0">
                 <a:solidFill>
                   <a:srgbClr val="334155"/>
                 </a:solidFill>
@@ -2203,23 +2390,65 @@
                 <a:ea typeface="Segoe UI" pitchFamily="34" charset="-122"/>
                 <a:cs typeface="Segoe UI" pitchFamily="34" charset="-120"/>
               </a:rPr>
-              <a:t>Motor de análisis local y determinista (lexicón curado, sin "caja negra").</a:t>
-            </a:r>
-            <a:endParaRPr lang="en-US" sz="1900" dirty="0"/>
-          </a:p>
-          <a:p>
-            <a:pPr marL="228600" indent="-228600">
-              <a:lnSpc>
-                <a:spcPct val="115000"/>
-              </a:lnSpc>
-              <a:spcAft>
-                <a:spcPts val="1000"/>
-              </a:spcAft>
-              <a:buSzPct val="100000"/>
-              <a:buChar char="•"/>
-            </a:pPr>
-            <a:r>
-              <a:rPr lang="en-US" sz="1900" dirty="0">
+              <a:t>Next.js 15</a:t>
+            </a:r>
+            <a:endParaRPr lang="en-US" sz="1250" dirty="0"/>
+          </a:p>
+        </p:txBody>
+      </p:sp>
+      <p:sp>
+        <p:nvSpPr>
+          <p:cNvPr id="7" name="Shape 5"/>
+          <p:cNvSpPr/>
+          <p:nvPr/>
+        </p:nvSpPr>
+        <p:spPr>
+          <a:xfrm>
+            <a:off x="4251960" y="1755648"/>
+            <a:ext cx="1225296" cy="420624"/>
+          </a:xfrm>
+          <a:prstGeom prst="roundRect">
+            <a:avLst>
+              <a:gd name="adj" fmla="val 50000"/>
+            </a:avLst>
+          </a:prstGeom>
+          <a:solidFill>
+            <a:srgbClr val="F1F5F9"/>
+          </a:solidFill>
+          <a:ln w="12700">
+            <a:solidFill>
+              <a:srgbClr val="E2E8F0"/>
+            </a:solidFill>
+            <a:prstDash val="solid"/>
+          </a:ln>
+        </p:spPr>
+      </p:sp>
+      <p:sp>
+        <p:nvSpPr>
+          <p:cNvPr id="8" name="Text 6"/>
+          <p:cNvSpPr/>
+          <p:nvPr/>
+        </p:nvSpPr>
+        <p:spPr>
+          <a:xfrm>
+            <a:off x="4251960" y="1755648"/>
+            <a:ext cx="1225296" cy="420624"/>
+          </a:xfrm>
+          <a:prstGeom prst="rect">
+            <a:avLst/>
+          </a:prstGeom>
+          <a:noFill/>
+          <a:ln/>
+        </p:spPr>
+        <p:txBody>
+          <a:bodyPr wrap="square" rtlCol="0" anchor="ctr"/>
+          <a:lstStyle/>
+          <a:p>
+            <a:pPr algn="ctr" indent="0" marL="0">
+              <a:buNone/>
+            </a:pPr>
+            <a:r>
+              <a:rPr lang="en-US" sz="1250" dirty="0">
                 <a:solidFill>
                   <a:srgbClr val="334155"/>
                 </a:solidFill>
@@ -2227,23 +2456,65 @@
                 <a:ea typeface="Segoe UI" pitchFamily="34" charset="-122"/>
                 <a:cs typeface="Segoe UI" pitchFamily="34" charset="-120"/>
               </a:rPr>
-              <a:t>Degradación elegante: BBDD e IA opcionales; la app nunca depende de ellas.</a:t>
-            </a:r>
-            <a:endParaRPr lang="en-US" sz="1900" dirty="0"/>
-          </a:p>
-          <a:p>
-            <a:pPr marL="228600" indent="-228600">
-              <a:lnSpc>
-                <a:spcPct val="115000"/>
-              </a:lnSpc>
-              <a:spcAft>
-                <a:spcPts val="1000"/>
-              </a:spcAft>
-              <a:buSzPct val="100000"/>
-              <a:buChar char="•"/>
-            </a:pPr>
-            <a:r>
-              <a:rPr lang="en-US" sz="1900" dirty="0">
+              <a:t>React 19</a:t>
+            </a:r>
+            <a:endParaRPr lang="en-US" sz="1250" dirty="0"/>
+          </a:p>
+        </p:txBody>
+      </p:sp>
+      <p:sp>
+        <p:nvSpPr>
+          <p:cNvPr id="9" name="Shape 7"/>
+          <p:cNvSpPr/>
+          <p:nvPr/>
+        </p:nvSpPr>
+        <p:spPr>
+          <a:xfrm>
+            <a:off x="5660136" y="1755648"/>
+            <a:ext cx="1417320" cy="420624"/>
+          </a:xfrm>
+          <a:prstGeom prst="roundRect">
+            <a:avLst>
+              <a:gd name="adj" fmla="val 50000"/>
+            </a:avLst>
+          </a:prstGeom>
+          <a:solidFill>
+            <a:srgbClr val="F1F5F9"/>
+          </a:solidFill>
+          <a:ln w="12700">
+            <a:solidFill>
+              <a:srgbClr val="E2E8F0"/>
+            </a:solidFill>
+            <a:prstDash val="solid"/>
+          </a:ln>
+        </p:spPr>
+      </p:sp>
+      <p:sp>
+        <p:nvSpPr>
+          <p:cNvPr id="10" name="Text 8"/>
+          <p:cNvSpPr/>
+          <p:nvPr/>
+        </p:nvSpPr>
+        <p:spPr>
+          <a:xfrm>
+            <a:off x="5660136" y="1755648"/>
+            <a:ext cx="1417320" cy="420624"/>
+          </a:xfrm>
+          <a:prstGeom prst="rect">
+            <a:avLst/>
+          </a:prstGeom>
+          <a:noFill/>
+          <a:ln/>
+        </p:spPr>
+        <p:txBody>
+          <a:bodyPr wrap="square" rtlCol="0" anchor="ctr"/>
+          <a:lstStyle/>
+          <a:p>
+            <a:pPr algn="ctr" indent="0" marL="0">
+              <a:buNone/>
+            </a:pPr>
+            <a:r>
+              <a:rPr lang="en-US" sz="1250" dirty="0">
                 <a:solidFill>
                   <a:srgbClr val="334155"/>
                 </a:solidFill>
@@ -2251,23 +2522,65 @@
                 <a:ea typeface="Segoe UI" pitchFamily="34" charset="-122"/>
                 <a:cs typeface="Segoe UI" pitchFamily="34" charset="-120"/>
               </a:rPr>
-              <a:t>Auth con JWT sin base de datos y usuario semilla.</a:t>
-            </a:r>
-            <a:endParaRPr lang="en-US" sz="1900" dirty="0"/>
-          </a:p>
-          <a:p>
-            <a:pPr marL="228600" indent="-228600">
-              <a:lnSpc>
-                <a:spcPct val="115000"/>
-              </a:lnSpc>
-              <a:spcAft>
-                <a:spcPts val="1000"/>
-              </a:spcAft>
-              <a:buSzPct val="100000"/>
-              <a:buChar char="•"/>
-            </a:pPr>
-            <a:r>
-              <a:rPr lang="en-US" sz="1900" dirty="0">
+              <a:t>TypeScript</a:t>
+            </a:r>
+            <a:endParaRPr lang="en-US" sz="1250" dirty="0"/>
+          </a:p>
+        </p:txBody>
+      </p:sp>
+      <p:sp>
+        <p:nvSpPr>
+          <p:cNvPr id="11" name="Shape 9"/>
+          <p:cNvSpPr/>
+          <p:nvPr/>
+        </p:nvSpPr>
+        <p:spPr>
+          <a:xfrm>
+            <a:off x="7260336" y="1755648"/>
+            <a:ext cx="1609344" cy="420624"/>
+          </a:xfrm>
+          <a:prstGeom prst="roundRect">
+            <a:avLst>
+              <a:gd name="adj" fmla="val 50000"/>
+            </a:avLst>
+          </a:prstGeom>
+          <a:solidFill>
+            <a:srgbClr val="F1F5F9"/>
+          </a:solidFill>
+          <a:ln w="12700">
+            <a:solidFill>
+              <a:srgbClr val="E2E8F0"/>
+            </a:solidFill>
+            <a:prstDash val="solid"/>
+          </a:ln>
+        </p:spPr>
+      </p:sp>
+      <p:sp>
+        <p:nvSpPr>
+          <p:cNvPr id="12" name="Text 10"/>
+          <p:cNvSpPr/>
+          <p:nvPr/>
+        </p:nvSpPr>
+        <p:spPr>
+          <a:xfrm>
+            <a:off x="7260336" y="1755648"/>
+            <a:ext cx="1609344" cy="420624"/>
+          </a:xfrm>
+          <a:prstGeom prst="rect">
+            <a:avLst/>
+          </a:prstGeom>
+          <a:noFill/>
+          <a:ln/>
+        </p:spPr>
+        <p:txBody>
+          <a:bodyPr wrap="square" rtlCol="0" anchor="ctr"/>
+          <a:lstStyle/>
+          <a:p>
+            <a:pPr algn="ctr" indent="0" marL="0">
+              <a:buNone/>
+            </a:pPr>
+            <a:r>
+              <a:rPr lang="en-US" sz="1250" dirty="0">
                 <a:solidFill>
                   <a:srgbClr val="334155"/>
                 </a:solidFill>
@@ -2275,23 +2588,104 @@
                 <a:ea typeface="Segoe UI" pitchFamily="34" charset="-122"/>
                 <a:cs typeface="Segoe UI" pitchFamily="34" charset="-120"/>
               </a:rPr>
-              <a:t>i18n español/inglés y modo claro/oscuro.</a:t>
-            </a:r>
-            <a:endParaRPr lang="en-US" sz="1900" dirty="0"/>
-          </a:p>
-          <a:p>
-            <a:pPr marL="228600" indent="-228600">
-              <a:lnSpc>
-                <a:spcPct val="115000"/>
-              </a:lnSpc>
-              <a:spcAft>
-                <a:spcPts val="1000"/>
-              </a:spcAft>
-              <a:buSzPct val="100000"/>
-              <a:buChar char="•"/>
-            </a:pPr>
-            <a:r>
-              <a:rPr lang="en-US" sz="1900" dirty="0">
+              <a:t>Tailwind CSS</a:t>
+            </a:r>
+            <a:endParaRPr lang="en-US" sz="1250" dirty="0"/>
+          </a:p>
+        </p:txBody>
+      </p:sp>
+      <p:sp>
+        <p:nvSpPr>
+          <p:cNvPr id="13" name="Text 11"/>
+          <p:cNvSpPr/>
+          <p:nvPr/>
+        </p:nvSpPr>
+        <p:spPr>
+          <a:xfrm>
+            <a:off x="731520" y="2450592"/>
+            <a:ext cx="1737360" cy="457200"/>
+          </a:xfrm>
+          <a:prstGeom prst="rect">
+            <a:avLst/>
+          </a:prstGeom>
+          <a:noFill/>
+          <a:ln/>
+        </p:spPr>
+        <p:txBody>
+          <a:bodyPr wrap="square" rtlCol="0" anchor="ctr"/>
+          <a:lstStyle/>
+          <a:p>
+            <a:pPr indent="0" marL="0">
+              <a:buNone/>
+            </a:pPr>
+            <a:r>
+              <a:rPr lang="en-US" sz="1500" b="1" dirty="0">
+                <a:solidFill>
+                  <a:srgbClr val="8B5CF6"/>
+                </a:solidFill>
+                <a:latin typeface="Segoe UI" pitchFamily="34" charset="0"/>
+                <a:ea typeface="Segoe UI" pitchFamily="34" charset="-122"/>
+                <a:cs typeface="Segoe UI" pitchFamily="34" charset="-120"/>
+              </a:rPr>
+              <a:t>Auth</a:t>
+            </a:r>
+            <a:endParaRPr lang="en-US" sz="1500" dirty="0"/>
+          </a:p>
+        </p:txBody>
+      </p:sp>
+      <p:sp>
+        <p:nvSpPr>
+          <p:cNvPr id="14" name="Shape 12"/>
+          <p:cNvSpPr/>
+          <p:nvPr/>
+        </p:nvSpPr>
+        <p:spPr>
+          <a:xfrm>
+            <a:off x="2651760" y="2468880"/>
+            <a:ext cx="2473452" cy="420624"/>
+          </a:xfrm>
+          <a:prstGeom prst="roundRect">
+            <a:avLst>
+              <a:gd name="adj" fmla="val 50000"/>
+            </a:avLst>
+          </a:prstGeom>
+          <a:solidFill>
+            <a:srgbClr val="F1F5F9"/>
+          </a:solidFill>
+          <a:ln w="12700">
+            <a:solidFill>
+              <a:srgbClr val="E2E8F0"/>
+            </a:solidFill>
+            <a:prstDash val="solid"/>
+          </a:ln>
+        </p:spPr>
+      </p:sp>
+      <p:sp>
+        <p:nvSpPr>
+          <p:cNvPr id="15" name="Text 13"/>
+          <p:cNvSpPr/>
+          <p:nvPr/>
+        </p:nvSpPr>
+        <p:spPr>
+          <a:xfrm>
+            <a:off x="2651760" y="2468880"/>
+            <a:ext cx="2473452" cy="420624"/>
+          </a:xfrm>
+          <a:prstGeom prst="rect">
+            <a:avLst/>
+          </a:prstGeom>
+          <a:noFill/>
+          <a:ln/>
+        </p:spPr>
+        <p:txBody>
+          <a:bodyPr wrap="square" rtlCol="0" anchor="ctr"/>
+          <a:lstStyle/>
+          <a:p>
+            <a:pPr algn="ctr" indent="0" marL="0">
+              <a:buNone/>
+            </a:pPr>
+            <a:r>
+              <a:rPr lang="en-US" sz="1250" dirty="0">
                 <a:solidFill>
                   <a:srgbClr val="334155"/>
                 </a:solidFill>
@@ -2299,22 +2693,861 @@
                 <a:ea typeface="Segoe UI" pitchFamily="34" charset="-122"/>
                 <a:cs typeface="Segoe UI" pitchFamily="34" charset="-120"/>
               </a:rPr>
-              <a:t>Tests del motor para ampliar el lexicón sin regresiones.</a:t>
-            </a:r>
-            <a:endParaRPr lang="en-US" sz="1900" dirty="0"/>
-          </a:p>
-        </p:txBody>
-      </p:sp>
-      <p:sp>
-        <p:nvSpPr>
-          <p:cNvPr id="5" name="Text 3"/>
+              <a:t>Auth.js (NextAuth v5)</a:t>
+            </a:r>
+            <a:endParaRPr lang="en-US" sz="1250" dirty="0"/>
+          </a:p>
+        </p:txBody>
+      </p:sp>
+      <p:sp>
+        <p:nvSpPr>
+          <p:cNvPr id="16" name="Shape 14"/>
+          <p:cNvSpPr/>
+          <p:nvPr/>
+        </p:nvSpPr>
+        <p:spPr>
+          <a:xfrm>
+            <a:off x="5308092" y="2468880"/>
+            <a:ext cx="1417320" cy="420624"/>
+          </a:xfrm>
+          <a:prstGeom prst="roundRect">
+            <a:avLst>
+              <a:gd name="adj" fmla="val 50000"/>
+            </a:avLst>
+          </a:prstGeom>
+          <a:solidFill>
+            <a:srgbClr val="F1F5F9"/>
+          </a:solidFill>
+          <a:ln w="12700">
+            <a:solidFill>
+              <a:srgbClr val="E2E8F0"/>
+            </a:solidFill>
+            <a:prstDash val="solid"/>
+          </a:ln>
+        </p:spPr>
+      </p:sp>
+      <p:sp>
+        <p:nvSpPr>
+          <p:cNvPr id="17" name="Text 15"/>
+          <p:cNvSpPr/>
+          <p:nvPr/>
+        </p:nvSpPr>
+        <p:spPr>
+          <a:xfrm>
+            <a:off x="5308092" y="2468880"/>
+            <a:ext cx="1417320" cy="420624"/>
+          </a:xfrm>
+          <a:prstGeom prst="rect">
+            <a:avLst/>
+          </a:prstGeom>
+          <a:noFill/>
+          <a:ln/>
+        </p:spPr>
+        <p:txBody>
+          <a:bodyPr wrap="square" rtlCol="0" anchor="ctr"/>
+          <a:lstStyle/>
+          <a:p>
+            <a:pPr algn="ctr" indent="0" marL="0">
+              <a:buNone/>
+            </a:pPr>
+            <a:r>
+              <a:rPr lang="en-US" sz="1250" dirty="0">
+                <a:solidFill>
+                  <a:srgbClr val="334155"/>
+                </a:solidFill>
+                <a:latin typeface="Segoe UI" pitchFamily="34" charset="0"/>
+                <a:ea typeface="Segoe UI" pitchFamily="34" charset="-122"/>
+                <a:cs typeface="Segoe UI" pitchFamily="34" charset="-120"/>
+              </a:rPr>
+              <a:t>Sesión JWT</a:t>
+            </a:r>
+            <a:endParaRPr lang="en-US" sz="1250" dirty="0"/>
+          </a:p>
+        </p:txBody>
+      </p:sp>
+      <p:sp>
+        <p:nvSpPr>
+          <p:cNvPr id="18" name="Text 16"/>
+          <p:cNvSpPr/>
+          <p:nvPr/>
+        </p:nvSpPr>
+        <p:spPr>
+          <a:xfrm>
+            <a:off x="731520" y="3163824"/>
+            <a:ext cx="1737360" cy="457200"/>
+          </a:xfrm>
+          <a:prstGeom prst="rect">
+            <a:avLst/>
+          </a:prstGeom>
+          <a:noFill/>
+          <a:ln/>
+        </p:spPr>
+        <p:txBody>
+          <a:bodyPr wrap="square" rtlCol="0" anchor="ctr"/>
+          <a:lstStyle/>
+          <a:p>
+            <a:pPr indent="0" marL="0">
+              <a:buNone/>
+            </a:pPr>
+            <a:r>
+              <a:rPr lang="en-US" sz="1500" b="1" dirty="0">
+                <a:solidFill>
+                  <a:srgbClr val="0EA5E9"/>
+                </a:solidFill>
+                <a:latin typeface="Segoe UI" pitchFamily="34" charset="0"/>
+                <a:ea typeface="Segoe UI" pitchFamily="34" charset="-122"/>
+                <a:cs typeface="Segoe UI" pitchFamily="34" charset="-120"/>
+              </a:rPr>
+              <a:t>Datos</a:t>
+            </a:r>
+            <a:endParaRPr lang="en-US" sz="1500" dirty="0"/>
+          </a:p>
+        </p:txBody>
+      </p:sp>
+      <p:sp>
+        <p:nvSpPr>
+          <p:cNvPr id="19" name="Shape 17"/>
+          <p:cNvSpPr/>
+          <p:nvPr/>
+        </p:nvSpPr>
+        <p:spPr>
+          <a:xfrm>
+            <a:off x="2651760" y="3182112"/>
+            <a:ext cx="1033272" cy="420624"/>
+          </a:xfrm>
+          <a:prstGeom prst="roundRect">
+            <a:avLst>
+              <a:gd name="adj" fmla="val 50000"/>
+            </a:avLst>
+          </a:prstGeom>
+          <a:solidFill>
+            <a:srgbClr val="F1F5F9"/>
+          </a:solidFill>
+          <a:ln w="12700">
+            <a:solidFill>
+              <a:srgbClr val="E2E8F0"/>
+            </a:solidFill>
+            <a:prstDash val="solid"/>
+          </a:ln>
+        </p:spPr>
+      </p:sp>
+      <p:sp>
+        <p:nvSpPr>
+          <p:cNvPr id="20" name="Text 18"/>
+          <p:cNvSpPr/>
+          <p:nvPr/>
+        </p:nvSpPr>
+        <p:spPr>
+          <a:xfrm>
+            <a:off x="2651760" y="3182112"/>
+            <a:ext cx="1033272" cy="420624"/>
+          </a:xfrm>
+          <a:prstGeom prst="rect">
+            <a:avLst/>
+          </a:prstGeom>
+          <a:noFill/>
+          <a:ln/>
+        </p:spPr>
+        <p:txBody>
+          <a:bodyPr wrap="square" rtlCol="0" anchor="ctr"/>
+          <a:lstStyle/>
+          <a:p>
+            <a:pPr algn="ctr" indent="0" marL="0">
+              <a:buNone/>
+            </a:pPr>
+            <a:r>
+              <a:rPr lang="en-US" sz="1250" dirty="0">
+                <a:solidFill>
+                  <a:srgbClr val="334155"/>
+                </a:solidFill>
+                <a:latin typeface="Segoe UI" pitchFamily="34" charset="0"/>
+                <a:ea typeface="Segoe UI" pitchFamily="34" charset="-122"/>
+                <a:cs typeface="Segoe UI" pitchFamily="34" charset="-120"/>
+              </a:rPr>
+              <a:t>Prisma</a:t>
+            </a:r>
+            <a:endParaRPr lang="en-US" sz="1250" dirty="0"/>
+          </a:p>
+        </p:txBody>
+      </p:sp>
+      <p:sp>
+        <p:nvSpPr>
+          <p:cNvPr id="21" name="Shape 19"/>
+          <p:cNvSpPr/>
+          <p:nvPr/>
+        </p:nvSpPr>
+        <p:spPr>
+          <a:xfrm>
+            <a:off x="3867912" y="3182112"/>
+            <a:ext cx="2473452" cy="420624"/>
+          </a:xfrm>
+          <a:prstGeom prst="roundRect">
+            <a:avLst>
+              <a:gd name="adj" fmla="val 50000"/>
+            </a:avLst>
+          </a:prstGeom>
+          <a:solidFill>
+            <a:srgbClr val="F1F5F9"/>
+          </a:solidFill>
+          <a:ln w="12700">
+            <a:solidFill>
+              <a:srgbClr val="E2E8F0"/>
+            </a:solidFill>
+            <a:prstDash val="solid"/>
+          </a:ln>
+        </p:spPr>
+      </p:sp>
+      <p:sp>
+        <p:nvSpPr>
+          <p:cNvPr id="22" name="Text 20"/>
+          <p:cNvSpPr/>
+          <p:nvPr/>
+        </p:nvSpPr>
+        <p:spPr>
+          <a:xfrm>
+            <a:off x="3867912" y="3182112"/>
+            <a:ext cx="2473452" cy="420624"/>
+          </a:xfrm>
+          <a:prstGeom prst="rect">
+            <a:avLst/>
+          </a:prstGeom>
+          <a:noFill/>
+          <a:ln/>
+        </p:spPr>
+        <p:txBody>
+          <a:bodyPr wrap="square" rtlCol="0" anchor="ctr"/>
+          <a:lstStyle/>
+          <a:p>
+            <a:pPr algn="ctr" indent="0" marL="0">
+              <a:buNone/>
+            </a:pPr>
+            <a:r>
+              <a:rPr lang="en-US" sz="1250" dirty="0">
+                <a:solidFill>
+                  <a:srgbClr val="334155"/>
+                </a:solidFill>
+                <a:latin typeface="Segoe UI" pitchFamily="34" charset="0"/>
+                <a:ea typeface="Segoe UI" pitchFamily="34" charset="-122"/>
+                <a:cs typeface="Segoe UI" pitchFamily="34" charset="-120"/>
+              </a:rPr>
+              <a:t>PostgreSQL (opcional)</a:t>
+            </a:r>
+            <a:endParaRPr lang="en-US" sz="1250" dirty="0"/>
+          </a:p>
+        </p:txBody>
+      </p:sp>
+      <p:sp>
+        <p:nvSpPr>
+          <p:cNvPr id="23" name="Shape 21"/>
+          <p:cNvSpPr/>
+          <p:nvPr/>
+        </p:nvSpPr>
+        <p:spPr>
+          <a:xfrm>
+            <a:off x="6524244" y="3182112"/>
+            <a:ext cx="1609344" cy="420624"/>
+          </a:xfrm>
+          <a:prstGeom prst="roundRect">
+            <a:avLst>
+              <a:gd name="adj" fmla="val 50000"/>
+            </a:avLst>
+          </a:prstGeom>
+          <a:solidFill>
+            <a:srgbClr val="F1F5F9"/>
+          </a:solidFill>
+          <a:ln w="12700">
+            <a:solidFill>
+              <a:srgbClr val="E2E8F0"/>
+            </a:solidFill>
+            <a:prstDash val="solid"/>
+          </a:ln>
+        </p:spPr>
+      </p:sp>
+      <p:sp>
+        <p:nvSpPr>
+          <p:cNvPr id="24" name="Text 22"/>
+          <p:cNvSpPr/>
+          <p:nvPr/>
+        </p:nvSpPr>
+        <p:spPr>
+          <a:xfrm>
+            <a:off x="6524244" y="3182112"/>
+            <a:ext cx="1609344" cy="420624"/>
+          </a:xfrm>
+          <a:prstGeom prst="rect">
+            <a:avLst/>
+          </a:prstGeom>
+          <a:noFill/>
+          <a:ln/>
+        </p:spPr>
+        <p:txBody>
+          <a:bodyPr wrap="square" rtlCol="0" anchor="ctr"/>
+          <a:lstStyle/>
+          <a:p>
+            <a:pPr algn="ctr" indent="0" marL="0">
+              <a:buNone/>
+            </a:pPr>
+            <a:r>
+              <a:rPr lang="en-US" sz="1250" dirty="0">
+                <a:solidFill>
+                  <a:srgbClr val="334155"/>
+                </a:solidFill>
+                <a:latin typeface="Segoe UI" pitchFamily="34" charset="0"/>
+                <a:ea typeface="Segoe UI" pitchFamily="34" charset="-122"/>
+                <a:cs typeface="Segoe UI" pitchFamily="34" charset="-120"/>
+              </a:rPr>
+              <a:t>localStorage</a:t>
+            </a:r>
+            <a:endParaRPr lang="en-US" sz="1250" dirty="0"/>
+          </a:p>
+        </p:txBody>
+      </p:sp>
+      <p:sp>
+        <p:nvSpPr>
+          <p:cNvPr id="25" name="Text 23"/>
+          <p:cNvSpPr/>
+          <p:nvPr/>
+        </p:nvSpPr>
+        <p:spPr>
+          <a:xfrm>
+            <a:off x="731520" y="3877056"/>
+            <a:ext cx="1737360" cy="457200"/>
+          </a:xfrm>
+          <a:prstGeom prst="rect">
+            <a:avLst/>
+          </a:prstGeom>
+          <a:noFill/>
+          <a:ln/>
+        </p:spPr>
+        <p:txBody>
+          <a:bodyPr wrap="square" rtlCol="0" anchor="ctr"/>
+          <a:lstStyle/>
+          <a:p>
+            <a:pPr indent="0" marL="0">
+              <a:buNone/>
+            </a:pPr>
+            <a:r>
+              <a:rPr lang="en-US" sz="1500" b="1" dirty="0">
+                <a:solidFill>
+                  <a:srgbClr val="16A34A"/>
+                </a:solidFill>
+                <a:latin typeface="Segoe UI" pitchFamily="34" charset="0"/>
+                <a:ea typeface="Segoe UI" pitchFamily="34" charset="-122"/>
+                <a:cs typeface="Segoe UI" pitchFamily="34" charset="-120"/>
+              </a:rPr>
+              <a:t>IA</a:t>
+            </a:r>
+            <a:endParaRPr lang="en-US" sz="1500" dirty="0"/>
+          </a:p>
+        </p:txBody>
+      </p:sp>
+      <p:sp>
+        <p:nvSpPr>
+          <p:cNvPr id="26" name="Shape 24"/>
+          <p:cNvSpPr/>
+          <p:nvPr/>
+        </p:nvSpPr>
+        <p:spPr>
+          <a:xfrm>
+            <a:off x="2651760" y="3895344"/>
+            <a:ext cx="1225296" cy="420624"/>
+          </a:xfrm>
+          <a:prstGeom prst="roundRect">
+            <a:avLst>
+              <a:gd name="adj" fmla="val 50000"/>
+            </a:avLst>
+          </a:prstGeom>
+          <a:solidFill>
+            <a:srgbClr val="F1F5F9"/>
+          </a:solidFill>
+          <a:ln w="12700">
+            <a:solidFill>
+              <a:srgbClr val="E2E8F0"/>
+            </a:solidFill>
+            <a:prstDash val="solid"/>
+          </a:ln>
+        </p:spPr>
+      </p:sp>
+      <p:sp>
+        <p:nvSpPr>
+          <p:cNvPr id="27" name="Text 25"/>
+          <p:cNvSpPr/>
+          <p:nvPr/>
+        </p:nvSpPr>
+        <p:spPr>
+          <a:xfrm>
+            <a:off x="2651760" y="3895344"/>
+            <a:ext cx="1225296" cy="420624"/>
+          </a:xfrm>
+          <a:prstGeom prst="rect">
+            <a:avLst/>
+          </a:prstGeom>
+          <a:noFill/>
+          <a:ln/>
+        </p:spPr>
+        <p:txBody>
+          <a:bodyPr wrap="square" rtlCol="0" anchor="ctr"/>
+          <a:lstStyle/>
+          <a:p>
+            <a:pPr algn="ctr" indent="0" marL="0">
+              <a:buNone/>
+            </a:pPr>
+            <a:r>
+              <a:rPr lang="en-US" sz="1250" dirty="0">
+                <a:solidFill>
+                  <a:srgbClr val="334155"/>
+                </a:solidFill>
+                <a:latin typeface="Segoe UI" pitchFamily="34" charset="0"/>
+                <a:ea typeface="Segoe UI" pitchFamily="34" charset="-122"/>
+                <a:cs typeface="Segoe UI" pitchFamily="34" charset="-120"/>
+              </a:rPr>
+              <a:t>Groq API</a:t>
+            </a:r>
+            <a:endParaRPr lang="en-US" sz="1250" dirty="0"/>
+          </a:p>
+        </p:txBody>
+      </p:sp>
+      <p:sp>
+        <p:nvSpPr>
+          <p:cNvPr id="28" name="Shape 26"/>
+          <p:cNvSpPr/>
+          <p:nvPr/>
+        </p:nvSpPr>
+        <p:spPr>
+          <a:xfrm>
+            <a:off x="4059936" y="3895344"/>
+            <a:ext cx="1801368" cy="420624"/>
+          </a:xfrm>
+          <a:prstGeom prst="roundRect">
+            <a:avLst>
+              <a:gd name="adj" fmla="val 50000"/>
+            </a:avLst>
+          </a:prstGeom>
+          <a:solidFill>
+            <a:srgbClr val="F1F5F9"/>
+          </a:solidFill>
+          <a:ln w="12700">
+            <a:solidFill>
+              <a:srgbClr val="E2E8F0"/>
+            </a:solidFill>
+            <a:prstDash val="solid"/>
+          </a:ln>
+        </p:spPr>
+      </p:sp>
+      <p:sp>
+        <p:nvSpPr>
+          <p:cNvPr id="29" name="Text 27"/>
+          <p:cNvSpPr/>
+          <p:nvPr/>
+        </p:nvSpPr>
+        <p:spPr>
+          <a:xfrm>
+            <a:off x="4059936" y="3895344"/>
+            <a:ext cx="1801368" cy="420624"/>
+          </a:xfrm>
+          <a:prstGeom prst="rect">
+            <a:avLst/>
+          </a:prstGeom>
+          <a:noFill/>
+          <a:ln/>
+        </p:spPr>
+        <p:txBody>
+          <a:bodyPr wrap="square" rtlCol="0" anchor="ctr"/>
+          <a:lstStyle/>
+          <a:p>
+            <a:pPr algn="ctr" indent="0" marL="0">
+              <a:buNone/>
+            </a:pPr>
+            <a:r>
+              <a:rPr lang="en-US" sz="1250" dirty="0">
+                <a:solidFill>
+                  <a:srgbClr val="334155"/>
+                </a:solidFill>
+                <a:latin typeface="Segoe UI" pitchFamily="34" charset="0"/>
+                <a:ea typeface="Segoe UI" pitchFamily="34" charset="-122"/>
+                <a:cs typeface="Segoe UI" pitchFamily="34" charset="-120"/>
+              </a:rPr>
+              <a:t>Ollama (local)</a:t>
+            </a:r>
+            <a:endParaRPr lang="en-US" sz="1250" dirty="0"/>
+          </a:p>
+        </p:txBody>
+      </p:sp>
+      <p:sp>
+        <p:nvSpPr>
+          <p:cNvPr id="30" name="Text 28"/>
+          <p:cNvSpPr/>
+          <p:nvPr/>
+        </p:nvSpPr>
+        <p:spPr>
+          <a:xfrm>
+            <a:off x="731520" y="4590288"/>
+            <a:ext cx="1737360" cy="457200"/>
+          </a:xfrm>
+          <a:prstGeom prst="rect">
+            <a:avLst/>
+          </a:prstGeom>
+          <a:noFill/>
+          <a:ln/>
+        </p:spPr>
+        <p:txBody>
+          <a:bodyPr wrap="square" rtlCol="0" anchor="ctr"/>
+          <a:lstStyle/>
+          <a:p>
+            <a:pPr indent="0" marL="0">
+              <a:buNone/>
+            </a:pPr>
+            <a:r>
+              <a:rPr lang="en-US" sz="1500" b="1" dirty="0">
+                <a:solidFill>
+                  <a:srgbClr val="F59E0B"/>
+                </a:solidFill>
+                <a:latin typeface="Segoe UI" pitchFamily="34" charset="0"/>
+                <a:ea typeface="Segoe UI" pitchFamily="34" charset="-122"/>
+                <a:cs typeface="Segoe UI" pitchFamily="34" charset="-120"/>
+              </a:rPr>
+              <a:t>Calidad</a:t>
+            </a:r>
+            <a:endParaRPr lang="en-US" sz="1500" dirty="0"/>
+          </a:p>
+        </p:txBody>
+      </p:sp>
+      <p:sp>
+        <p:nvSpPr>
+          <p:cNvPr id="31" name="Shape 29"/>
+          <p:cNvSpPr/>
+          <p:nvPr/>
+        </p:nvSpPr>
+        <p:spPr>
+          <a:xfrm>
+            <a:off x="2651760" y="4608576"/>
+            <a:ext cx="1033272" cy="420624"/>
+          </a:xfrm>
+          <a:prstGeom prst="roundRect">
+            <a:avLst>
+              <a:gd name="adj" fmla="val 50000"/>
+            </a:avLst>
+          </a:prstGeom>
+          <a:solidFill>
+            <a:srgbClr val="F1F5F9"/>
+          </a:solidFill>
+          <a:ln w="12700">
+            <a:solidFill>
+              <a:srgbClr val="E2E8F0"/>
+            </a:solidFill>
+            <a:prstDash val="solid"/>
+          </a:ln>
+        </p:spPr>
+      </p:sp>
+      <p:sp>
+        <p:nvSpPr>
+          <p:cNvPr id="32" name="Text 30"/>
+          <p:cNvSpPr/>
+          <p:nvPr/>
+        </p:nvSpPr>
+        <p:spPr>
+          <a:xfrm>
+            <a:off x="2651760" y="4608576"/>
+            <a:ext cx="1033272" cy="420624"/>
+          </a:xfrm>
+          <a:prstGeom prst="rect">
+            <a:avLst/>
+          </a:prstGeom>
+          <a:noFill/>
+          <a:ln/>
+        </p:spPr>
+        <p:txBody>
+          <a:bodyPr wrap="square" rtlCol="0" anchor="ctr"/>
+          <a:lstStyle/>
+          <a:p>
+            <a:pPr algn="ctr" indent="0" marL="0">
+              <a:buNone/>
+            </a:pPr>
+            <a:r>
+              <a:rPr lang="en-US" sz="1250" dirty="0">
+                <a:solidFill>
+                  <a:srgbClr val="334155"/>
+                </a:solidFill>
+                <a:latin typeface="Segoe UI" pitchFamily="34" charset="0"/>
+                <a:ea typeface="Segoe UI" pitchFamily="34" charset="-122"/>
+                <a:cs typeface="Segoe UI" pitchFamily="34" charset="-120"/>
+              </a:rPr>
+              <a:t>Vitest</a:t>
+            </a:r>
+            <a:endParaRPr lang="en-US" sz="1250" dirty="0"/>
+          </a:p>
+        </p:txBody>
+      </p:sp>
+      <p:sp>
+        <p:nvSpPr>
+          <p:cNvPr id="33" name="Shape 31"/>
+          <p:cNvSpPr/>
+          <p:nvPr/>
+        </p:nvSpPr>
+        <p:spPr>
+          <a:xfrm>
+            <a:off x="3867912" y="4608576"/>
+            <a:ext cx="841248" cy="420624"/>
+          </a:xfrm>
+          <a:prstGeom prst="roundRect">
+            <a:avLst>
+              <a:gd name="adj" fmla="val 50000"/>
+            </a:avLst>
+          </a:prstGeom>
+          <a:solidFill>
+            <a:srgbClr val="F1F5F9"/>
+          </a:solidFill>
+          <a:ln w="12700">
+            <a:solidFill>
+              <a:srgbClr val="E2E8F0"/>
+            </a:solidFill>
+            <a:prstDash val="solid"/>
+          </a:ln>
+        </p:spPr>
+      </p:sp>
+      <p:sp>
+        <p:nvSpPr>
+          <p:cNvPr id="34" name="Text 32"/>
+          <p:cNvSpPr/>
+          <p:nvPr/>
+        </p:nvSpPr>
+        <p:spPr>
+          <a:xfrm>
+            <a:off x="3867912" y="4608576"/>
+            <a:ext cx="841248" cy="420624"/>
+          </a:xfrm>
+          <a:prstGeom prst="rect">
+            <a:avLst/>
+          </a:prstGeom>
+          <a:noFill/>
+          <a:ln/>
+        </p:spPr>
+        <p:txBody>
+          <a:bodyPr wrap="square" rtlCol="0" anchor="ctr"/>
+          <a:lstStyle/>
+          <a:p>
+            <a:pPr algn="ctr" indent="0" marL="0">
+              <a:buNone/>
+            </a:pPr>
+            <a:r>
+              <a:rPr lang="en-US" sz="1250" dirty="0">
+                <a:solidFill>
+                  <a:srgbClr val="334155"/>
+                </a:solidFill>
+                <a:latin typeface="Segoe UI" pitchFamily="34" charset="0"/>
+                <a:ea typeface="Segoe UI" pitchFamily="34" charset="-122"/>
+                <a:cs typeface="Segoe UI" pitchFamily="34" charset="-120"/>
+              </a:rPr>
+              <a:t>docx</a:t>
+            </a:r>
+            <a:endParaRPr lang="en-US" sz="1250" dirty="0"/>
+          </a:p>
+        </p:txBody>
+      </p:sp>
+      <p:sp>
+        <p:nvSpPr>
+          <p:cNvPr id="35" name="Shape 33"/>
+          <p:cNvSpPr/>
+          <p:nvPr/>
+        </p:nvSpPr>
+        <p:spPr>
+          <a:xfrm>
+            <a:off x="4892040" y="4608576"/>
+            <a:ext cx="1033272" cy="420624"/>
+          </a:xfrm>
+          <a:prstGeom prst="roundRect">
+            <a:avLst>
+              <a:gd name="adj" fmla="val 50000"/>
+            </a:avLst>
+          </a:prstGeom>
+          <a:solidFill>
+            <a:srgbClr val="F1F5F9"/>
+          </a:solidFill>
+          <a:ln w="12700">
+            <a:solidFill>
+              <a:srgbClr val="E2E8F0"/>
+            </a:solidFill>
+            <a:prstDash val="solid"/>
+          </a:ln>
+        </p:spPr>
+      </p:sp>
+      <p:sp>
+        <p:nvSpPr>
+          <p:cNvPr id="36" name="Text 34"/>
+          <p:cNvSpPr/>
+          <p:nvPr/>
+        </p:nvSpPr>
+        <p:spPr>
+          <a:xfrm>
+            <a:off x="4892040" y="4608576"/>
+            <a:ext cx="1033272" cy="420624"/>
+          </a:xfrm>
+          <a:prstGeom prst="rect">
+            <a:avLst/>
+          </a:prstGeom>
+          <a:noFill/>
+          <a:ln/>
+        </p:spPr>
+        <p:txBody>
+          <a:bodyPr wrap="square" rtlCol="0" anchor="ctr"/>
+          <a:lstStyle/>
+          <a:p>
+            <a:pPr algn="ctr" indent="0" marL="0">
+              <a:buNone/>
+            </a:pPr>
+            <a:r>
+              <a:rPr lang="en-US" sz="1250" dirty="0">
+                <a:solidFill>
+                  <a:srgbClr val="334155"/>
+                </a:solidFill>
+                <a:latin typeface="Segoe UI" pitchFamily="34" charset="0"/>
+                <a:ea typeface="Segoe UI" pitchFamily="34" charset="-122"/>
+                <a:cs typeface="Segoe UI" pitchFamily="34" charset="-120"/>
+              </a:rPr>
+              <a:t>ESLint</a:t>
+            </a:r>
+            <a:endParaRPr lang="en-US" sz="1250" dirty="0"/>
+          </a:p>
+        </p:txBody>
+      </p:sp>
+      <p:sp>
+        <p:nvSpPr>
+          <p:cNvPr id="37" name="Text 35"/>
+          <p:cNvSpPr/>
+          <p:nvPr/>
+        </p:nvSpPr>
+        <p:spPr>
+          <a:xfrm>
+            <a:off x="731520" y="5303520"/>
+            <a:ext cx="1737360" cy="457200"/>
+          </a:xfrm>
+          <a:prstGeom prst="rect">
+            <a:avLst/>
+          </a:prstGeom>
+          <a:noFill/>
+          <a:ln/>
+        </p:spPr>
+        <p:txBody>
+          <a:bodyPr wrap="square" rtlCol="0" anchor="ctr"/>
+          <a:lstStyle/>
+          <a:p>
+            <a:pPr indent="0" marL="0">
+              <a:buNone/>
+            </a:pPr>
+            <a:r>
+              <a:rPr lang="en-US" sz="1500" b="1" dirty="0">
+                <a:solidFill>
+                  <a:srgbClr val="EC4899"/>
+                </a:solidFill>
+                <a:latin typeface="Segoe UI" pitchFamily="34" charset="0"/>
+                <a:ea typeface="Segoe UI" pitchFamily="34" charset="-122"/>
+                <a:cs typeface="Segoe UI" pitchFamily="34" charset="-120"/>
+              </a:rPr>
+              <a:t>Deploy</a:t>
+            </a:r>
+            <a:endParaRPr lang="en-US" sz="1500" dirty="0"/>
+          </a:p>
+        </p:txBody>
+      </p:sp>
+      <p:sp>
+        <p:nvSpPr>
+          <p:cNvPr id="38" name="Shape 36"/>
+          <p:cNvSpPr/>
+          <p:nvPr/>
+        </p:nvSpPr>
+        <p:spPr>
+          <a:xfrm>
+            <a:off x="2651760" y="5321808"/>
+            <a:ext cx="1033272" cy="420624"/>
+          </a:xfrm>
+          <a:prstGeom prst="roundRect">
+            <a:avLst>
+              <a:gd name="adj" fmla="val 50000"/>
+            </a:avLst>
+          </a:prstGeom>
+          <a:solidFill>
+            <a:srgbClr val="F1F5F9"/>
+          </a:solidFill>
+          <a:ln w="12700">
+            <a:solidFill>
+              <a:srgbClr val="E2E8F0"/>
+            </a:solidFill>
+            <a:prstDash val="solid"/>
+          </a:ln>
+        </p:spPr>
+      </p:sp>
+      <p:sp>
+        <p:nvSpPr>
+          <p:cNvPr id="39" name="Text 37"/>
+          <p:cNvSpPr/>
+          <p:nvPr/>
+        </p:nvSpPr>
+        <p:spPr>
+          <a:xfrm>
+            <a:off x="2651760" y="5321808"/>
+            <a:ext cx="1033272" cy="420624"/>
+          </a:xfrm>
+          <a:prstGeom prst="rect">
+            <a:avLst/>
+          </a:prstGeom>
+          <a:noFill/>
+          <a:ln/>
+        </p:spPr>
+        <p:txBody>
+          <a:bodyPr wrap="square" rtlCol="0" anchor="ctr"/>
+          <a:lstStyle/>
+          <a:p>
+            <a:pPr algn="ctr" indent="0" marL="0">
+              <a:buNone/>
+            </a:pPr>
+            <a:r>
+              <a:rPr lang="en-US" sz="1250" dirty="0">
+                <a:solidFill>
+                  <a:srgbClr val="334155"/>
+                </a:solidFill>
+                <a:latin typeface="Segoe UI" pitchFamily="34" charset="0"/>
+                <a:ea typeface="Segoe UI" pitchFamily="34" charset="-122"/>
+                <a:cs typeface="Segoe UI" pitchFamily="34" charset="-120"/>
+              </a:rPr>
+              <a:t>Vercel</a:t>
+            </a:r>
+            <a:endParaRPr lang="en-US" sz="1250" dirty="0"/>
+          </a:p>
+        </p:txBody>
+      </p:sp>
+      <p:sp>
+        <p:nvSpPr>
+          <p:cNvPr id="40" name="Shape 38"/>
+          <p:cNvSpPr/>
+          <p:nvPr/>
+        </p:nvSpPr>
+        <p:spPr>
+          <a:xfrm>
+            <a:off x="640080" y="6309360"/>
+            <a:ext cx="10908792" cy="0"/>
+          </a:xfrm>
+          <a:prstGeom prst="line">
+            <a:avLst/>
+          </a:prstGeom>
+          <a:noFill/>
+          <a:ln w="12700">
+            <a:solidFill>
+              <a:srgbClr val="E2E8F0"/>
+            </a:solidFill>
+            <a:prstDash val="solid"/>
+          </a:ln>
+        </p:spPr>
+      </p:sp>
+      <p:sp>
+        <p:nvSpPr>
+          <p:cNvPr id="41" name="Text 39"/>
           <p:cNvSpPr/>
           <p:nvPr/>
         </p:nvSpPr>
         <p:spPr>
           <a:xfrm>
             <a:off x="640080" y="6400800"/>
-            <a:ext cx="7315200" cy="274320"/>
+            <a:ext cx="8229600" cy="274320"/>
           </a:xfrm>
           <a:prstGeom prst="rect">
             <a:avLst/>
@@ -2346,7 +3579,7 @@
       </p:sp>
       <p:sp>
         <p:nvSpPr>
-          <p:cNvPr id="6" name="Text 4"/>
+          <p:cNvPr id="42" name="Text 40"/>
           <p:cNvSpPr/>
           <p:nvPr/>
         </p:nvSpPr>
@@ -2468,7 +3701,7 @@
                 <a:ea typeface="Segoe UI" pitchFamily="34" charset="-122"/>
                 <a:cs typeface="Segoe UI" pitchFamily="34" charset="-120"/>
               </a:rPr>
-              <a:t>Enlaces</a:t>
+              <a:t>Decisiones técnicas</a:t>
             </a:r>
             <a:endParaRPr lang="en-US" sz="3000" dirty="0"/>
           </a:p>
@@ -2483,7 +3716,7 @@
         <p:spPr>
           <a:xfrm>
             <a:off x="822960" y="1737360"/>
-            <a:ext cx="10515600" cy="4206240"/>
+            <a:ext cx="10515600" cy="4023360"/>
           </a:xfrm>
           <a:prstGeom prst="rect">
             <a:avLst/>
@@ -2514,7 +3747,7 @@
                 <a:ea typeface="Segoe UI" pitchFamily="34" charset="-122"/>
                 <a:cs typeface="Segoe UI" pitchFamily="34" charset="-120"/>
               </a:rPr>
-              <a:t>Repositorio: https://github.com/Jguita65/joblens</a:t>
+              <a:t>Motor de análisis local y determinista (lexicón curado, sin "caja negra").</a:t>
             </a:r>
             <a:endParaRPr lang="en-US" sz="1900" dirty="0"/>
           </a:p>
@@ -2538,7 +3771,7 @@
                 <a:ea typeface="Segoe UI" pitchFamily="34" charset="-122"/>
                 <a:cs typeface="Segoe UI" pitchFamily="34" charset="-120"/>
               </a:rPr>
-              <a:t>App: https://joblens-puce.vercel.app</a:t>
+              <a:t>IA opcional y desacoplada: Groq en la nube o Ollama en local, con degradación elegante.</a:t>
             </a:r>
             <a:endParaRPr lang="en-US" sz="1900" dirty="0"/>
           </a:p>
@@ -2562,22 +3795,69 @@
                 <a:ea typeface="Segoe UI" pitchFamily="34" charset="-122"/>
                 <a:cs typeface="Segoe UI" pitchFamily="34" charset="-120"/>
               </a:rPr>
-              <a:t>Cuenta de prueba: test@test.com / test1234</a:t>
+              <a:t>Degradación elegante también en datos: base de datos opcional (localStorage de reserva).</a:t>
             </a:r>
             <a:endParaRPr lang="en-US" sz="1900" dirty="0"/>
           </a:p>
-        </p:txBody>
-      </p:sp>
-      <p:sp>
-        <p:nvSpPr>
-          <p:cNvPr id="5" name="Text 3"/>
+          <a:p>
+            <a:pPr marL="228600" indent="-228600">
+              <a:lnSpc>
+                <a:spcPct val="115000"/>
+              </a:lnSpc>
+              <a:spcAft>
+                <a:spcPts val="1000"/>
+              </a:spcAft>
+              <a:buSzPct val="100000"/>
+              <a:buChar char="•"/>
+            </a:pPr>
+            <a:r>
+              <a:rPr lang="en-US" sz="1900" dirty="0">
+                <a:solidFill>
+                  <a:srgbClr val="334155"/>
+                </a:solidFill>
+                <a:latin typeface="Segoe UI" pitchFamily="34" charset="0"/>
+                <a:ea typeface="Segoe UI" pitchFamily="34" charset="-122"/>
+                <a:cs typeface="Segoe UI" pitchFamily="34" charset="-120"/>
+              </a:rPr>
+              <a:t>Auth con JWT sin base de datos; i18n español/inglés; tests del motor con Vitest.</a:t>
+            </a:r>
+            <a:endParaRPr lang="en-US" sz="1900" dirty="0"/>
+          </a:p>
+        </p:txBody>
+      </p:sp>
+      <p:sp>
+        <p:nvSpPr>
+          <p:cNvPr id="5" name="Shape 3"/>
+          <p:cNvSpPr/>
+          <p:nvPr/>
+        </p:nvSpPr>
+        <p:spPr>
+          <a:xfrm>
+            <a:off x="640080" y="6309360"/>
+            <a:ext cx="10908792" cy="0"/>
+          </a:xfrm>
+          <a:prstGeom prst="line">
+            <a:avLst/>
+          </a:prstGeom>
+          <a:noFill/>
+          <a:ln w="12700">
+            <a:solidFill>
+              <a:srgbClr val="E2E8F0"/>
+            </a:solidFill>
+            <a:prstDash val="solid"/>
+          </a:ln>
+        </p:spPr>
+      </p:sp>
+      <p:sp>
+        <p:nvSpPr>
+          <p:cNvPr id="6" name="Text 4"/>
           <p:cNvSpPr/>
           <p:nvPr/>
         </p:nvSpPr>
         <p:spPr>
           <a:xfrm>
             <a:off x="640080" y="6400800"/>
-            <a:ext cx="7315200" cy="274320"/>
+            <a:ext cx="8229600" cy="274320"/>
           </a:xfrm>
           <a:prstGeom prst="rect">
             <a:avLst/>
@@ -2609,7 +3889,7 @@
       </p:sp>
       <p:sp>
         <p:nvSpPr>
-          <p:cNvPr id="6" name="Text 4"/>
+          <p:cNvPr id="7" name="Text 5"/>
           <p:cNvSpPr/>
           <p:nvPr/>
         </p:nvSpPr>
@@ -2657,6 +3937,292 @@
 <file path=ppt/slides/slide12.xml><?xml version="1.0" encoding="utf-8"?>
 <p:sld xmlns:a="http://schemas.openxmlformats.org/drawingml/2006/main" xmlns:r="http://schemas.openxmlformats.org/officeDocument/2006/relationships" xmlns:p="http://schemas.openxmlformats.org/presentationml/2006/main">
   <p:cSld name="Slide 12">
+    <p:bg>
+      <p:bgPr>
+        <a:solidFill>
+          <a:srgbClr val="FFFFFF"/>
+        </a:solidFill>
+      </p:bgPr>
+    </p:bg>
+    <p:spTree>
+      <p:nvGrpSpPr>
+        <p:cNvPr id="1" name=""/>
+        <p:cNvGrpSpPr/>
+        <p:nvPr/>
+      </p:nvGrpSpPr>
+      <p:grpSpPr>
+        <a:xfrm>
+          <a:off x="0" y="0"/>
+          <a:ext cx="0" cy="0"/>
+          <a:chOff x="0" y="0"/>
+          <a:chExt cx="0" cy="0"/>
+        </a:xfrm>
+      </p:grpSpPr>
+      <p:sp>
+        <p:nvSpPr>
+          <p:cNvPr id="2" name="Shape 0"/>
+          <p:cNvSpPr/>
+          <p:nvPr/>
+        </p:nvSpPr>
+        <p:spPr>
+          <a:xfrm>
+            <a:off x="640080" y="566928"/>
+            <a:ext cx="502920" cy="109728"/>
+          </a:xfrm>
+          <a:prstGeom prst="rect">
+            <a:avLst/>
+          </a:prstGeom>
+          <a:solidFill>
+            <a:srgbClr val="4F46E5"/>
+          </a:solidFill>
+          <a:ln/>
+        </p:spPr>
+      </p:sp>
+      <p:sp>
+        <p:nvSpPr>
+          <p:cNvPr id="3" name="Text 1"/>
+          <p:cNvSpPr/>
+          <p:nvPr/>
+        </p:nvSpPr>
+        <p:spPr>
+          <a:xfrm>
+            <a:off x="640080" y="777240"/>
+            <a:ext cx="10972800" cy="731520"/>
+          </a:xfrm>
+          <a:prstGeom prst="rect">
+            <a:avLst/>
+          </a:prstGeom>
+          <a:noFill/>
+          <a:ln/>
+        </p:spPr>
+        <p:txBody>
+          <a:bodyPr wrap="square" rtlCol="0" anchor="ctr"/>
+          <a:lstStyle/>
+          <a:p>
+            <a:pPr indent="0" marL="0">
+              <a:buNone/>
+            </a:pPr>
+            <a:r>
+              <a:rPr lang="en-US" sz="3000" b="1" dirty="0">
+                <a:solidFill>
+                  <a:srgbClr val="0F172A"/>
+                </a:solidFill>
+                <a:latin typeface="Segoe UI" pitchFamily="34" charset="0"/>
+                <a:ea typeface="Segoe UI" pitchFamily="34" charset="-122"/>
+                <a:cs typeface="Segoe UI" pitchFamily="34" charset="-120"/>
+              </a:rPr>
+              <a:t>Enlaces</a:t>
+            </a:r>
+            <a:endParaRPr lang="en-US" sz="3000" dirty="0"/>
+          </a:p>
+        </p:txBody>
+      </p:sp>
+      <p:sp>
+        <p:nvSpPr>
+          <p:cNvPr id="4" name="Text 2"/>
+          <p:cNvSpPr/>
+          <p:nvPr/>
+        </p:nvSpPr>
+        <p:spPr>
+          <a:xfrm>
+            <a:off x="822960" y="1737360"/>
+            <a:ext cx="10515600" cy="4023360"/>
+          </a:xfrm>
+          <a:prstGeom prst="rect">
+            <a:avLst/>
+          </a:prstGeom>
+          <a:noFill/>
+          <a:ln/>
+        </p:spPr>
+        <p:txBody>
+          <a:bodyPr wrap="square" rtlCol="0" anchor="t"/>
+          <a:lstStyle/>
+          <a:p>
+            <a:pPr marL="228600" indent="-228600">
+              <a:lnSpc>
+                <a:spcPct val="115000"/>
+              </a:lnSpc>
+              <a:spcAft>
+                <a:spcPts val="1000"/>
+              </a:spcAft>
+              <a:buSzPct val="100000"/>
+              <a:buChar char="•"/>
+            </a:pPr>
+            <a:r>
+              <a:rPr lang="en-US" sz="1900" dirty="0">
+                <a:solidFill>
+                  <a:srgbClr val="334155"/>
+                </a:solidFill>
+                <a:latin typeface="Segoe UI" pitchFamily="34" charset="0"/>
+                <a:ea typeface="Segoe UI" pitchFamily="34" charset="-122"/>
+                <a:cs typeface="Segoe UI" pitchFamily="34" charset="-120"/>
+              </a:rPr>
+              <a:t>Repositorio: https://github.com/Jguita65/joblens</a:t>
+            </a:r>
+            <a:endParaRPr lang="en-US" sz="1900" dirty="0"/>
+          </a:p>
+          <a:p>
+            <a:pPr marL="228600" indent="-228600">
+              <a:lnSpc>
+                <a:spcPct val="115000"/>
+              </a:lnSpc>
+              <a:spcAft>
+                <a:spcPts val="1000"/>
+              </a:spcAft>
+              <a:buSzPct val="100000"/>
+              <a:buChar char="•"/>
+            </a:pPr>
+            <a:r>
+              <a:rPr lang="en-US" sz="1900" dirty="0">
+                <a:solidFill>
+                  <a:srgbClr val="334155"/>
+                </a:solidFill>
+                <a:latin typeface="Segoe UI" pitchFamily="34" charset="0"/>
+                <a:ea typeface="Segoe UI" pitchFamily="34" charset="-122"/>
+                <a:cs typeface="Segoe UI" pitchFamily="34" charset="-120"/>
+              </a:rPr>
+              <a:t>App: https://joblens-puce.vercel.app</a:t>
+            </a:r>
+            <a:endParaRPr lang="en-US" sz="1900" dirty="0"/>
+          </a:p>
+          <a:p>
+            <a:pPr marL="228600" indent="-228600">
+              <a:lnSpc>
+                <a:spcPct val="115000"/>
+              </a:lnSpc>
+              <a:spcAft>
+                <a:spcPts val="1000"/>
+              </a:spcAft>
+              <a:buSzPct val="100000"/>
+              <a:buChar char="•"/>
+            </a:pPr>
+            <a:r>
+              <a:rPr lang="en-US" sz="1900" dirty="0">
+                <a:solidFill>
+                  <a:srgbClr val="334155"/>
+                </a:solidFill>
+                <a:latin typeface="Segoe UI" pitchFamily="34" charset="0"/>
+                <a:ea typeface="Segoe UI" pitchFamily="34" charset="-122"/>
+                <a:cs typeface="Segoe UI" pitchFamily="34" charset="-120"/>
+              </a:rPr>
+              <a:t>Cuenta de prueba: test@test.com / test1234</a:t>
+            </a:r>
+            <a:endParaRPr lang="en-US" sz="1900" dirty="0"/>
+          </a:p>
+        </p:txBody>
+      </p:sp>
+      <p:sp>
+        <p:nvSpPr>
+          <p:cNvPr id="5" name="Shape 3"/>
+          <p:cNvSpPr/>
+          <p:nvPr/>
+        </p:nvSpPr>
+        <p:spPr>
+          <a:xfrm>
+            <a:off x="640080" y="6309360"/>
+            <a:ext cx="10908792" cy="0"/>
+          </a:xfrm>
+          <a:prstGeom prst="line">
+            <a:avLst/>
+          </a:prstGeom>
+          <a:noFill/>
+          <a:ln w="12700">
+            <a:solidFill>
+              <a:srgbClr val="E2E8F0"/>
+            </a:solidFill>
+            <a:prstDash val="solid"/>
+          </a:ln>
+        </p:spPr>
+      </p:sp>
+      <p:sp>
+        <p:nvSpPr>
+          <p:cNvPr id="6" name="Text 4"/>
+          <p:cNvSpPr/>
+          <p:nvPr/>
+        </p:nvSpPr>
+        <p:spPr>
+          <a:xfrm>
+            <a:off x="640080" y="6400800"/>
+            <a:ext cx="8229600" cy="274320"/>
+          </a:xfrm>
+          <a:prstGeom prst="rect">
+            <a:avLst/>
+          </a:prstGeom>
+          <a:noFill/>
+          <a:ln/>
+        </p:spPr>
+        <p:txBody>
+          <a:bodyPr wrap="square" rtlCol="0" anchor="ctr"/>
+          <a:lstStyle/>
+          <a:p>
+            <a:pPr indent="0" marL="0">
+              <a:buNone/>
+            </a:pPr>
+            <a:r>
+              <a:rPr lang="en-US" sz="900" dirty="0">
+                <a:solidFill>
+                  <a:srgbClr val="64748B"/>
+                </a:solidFill>
+                <a:latin typeface="Segoe UI" pitchFamily="34" charset="0"/>
+                <a:ea typeface="Segoe UI" pitchFamily="34" charset="-122"/>
+                <a:cs typeface="Segoe UI" pitchFamily="34" charset="-120"/>
+              </a:rPr>
+              <a:t>RecruitKit · TFM · Juan Ignacio Guitart</a:t>
+            </a:r>
+            <a:endParaRPr lang="en-US" sz="900" dirty="0"/>
+          </a:p>
+        </p:txBody>
+      </p:sp>
+      <p:sp>
+        <p:nvSpPr>
+          <p:cNvPr id="7" name="Text 5"/>
+          <p:cNvSpPr/>
+          <p:nvPr/>
+        </p:nvSpPr>
+        <p:spPr>
+          <a:xfrm>
+            <a:off x="11091672" y="6400800"/>
+            <a:ext cx="548640" cy="274320"/>
+          </a:xfrm>
+          <a:prstGeom prst="rect">
+            <a:avLst/>
+          </a:prstGeom>
+          <a:noFill/>
+          <a:ln/>
+        </p:spPr>
+        <p:txBody>
+          <a:bodyPr wrap="square" rtlCol="0" anchor="ctr"/>
+          <a:lstStyle/>
+          <a:p>
+            <a:pPr algn="r" indent="0" marL="0">
+              <a:buNone/>
+            </a:pPr>
+            <a:r>
+              <a:rPr lang="en-US" sz="900" dirty="0">
+                <a:solidFill>
+                  <a:srgbClr val="64748B"/>
+                </a:solidFill>
+                <a:latin typeface="Segoe UI" pitchFamily="34" charset="0"/>
+                <a:ea typeface="Segoe UI" pitchFamily="34" charset="-122"/>
+                <a:cs typeface="Segoe UI" pitchFamily="34" charset="-120"/>
+              </a:rPr>
+              <a:t>12</a:t>
+            </a:r>
+            <a:endParaRPr lang="en-US" sz="900" dirty="0"/>
+          </a:p>
+        </p:txBody>
+      </p:sp>
+    </p:spTree>
+  </p:cSld>
+  <p:clrMapOvr>
+    <a:masterClrMapping/>
+  </p:clrMapOvr>
+</p:sld>
+</file>
+
+<file path=ppt/slides/slide13.xml><?xml version="1.0" encoding="utf-8"?>
+<p:sld xmlns:a="http://schemas.openxmlformats.org/drawingml/2006/main" xmlns:r="http://schemas.openxmlformats.org/officeDocument/2006/relationships" xmlns:p="http://schemas.openxmlformats.org/presentationml/2006/main">
+  <p:cSld name="Slide 13">
     <p:bg>
       <p:bgPr>
         <a:solidFill>
@@ -2935,7 +4501,7 @@
         <p:spPr>
           <a:xfrm>
             <a:off x="822960" y="1737360"/>
-            <a:ext cx="10515600" cy="4206240"/>
+            <a:ext cx="10515600" cy="4023360"/>
           </a:xfrm>
           <a:prstGeom prst="rect">
             <a:avLst/>
@@ -2966,7 +4532,7 @@
                 <a:ea typeface="Segoe UI" pitchFamily="34" charset="-122"/>
                 <a:cs typeface="Segoe UI" pitchFamily="34" charset="-120"/>
               </a:rPr>
-              <a:t>Las ofertas de empleo contienen, a menudo sin querer, lenguaje sesgado (género, edad, capacitismo, jerga) que reduce la diversidad y puede ser ilegal.</a:t>
+              <a:t>Las ofertas de empleo contienen, a menudo sin querer, lenguaje sesgado (género, edad, capacitismo, jerga) que reduce la diversidad de candidaturas y puede ser ilegal.</a:t>
             </a:r>
             <a:endParaRPr lang="en-US" sz="1900" dirty="0"/>
           </a:p>
@@ -2994,18 +4560,65 @@
             </a:r>
             <a:endParaRPr lang="en-US" sz="1900" dirty="0"/>
           </a:p>
-        </p:txBody>
-      </p:sp>
-      <p:sp>
-        <p:nvSpPr>
-          <p:cNvPr id="5" name="Text 3"/>
+          <a:p>
+            <a:pPr marL="228600" indent="-228600">
+              <a:lnSpc>
+                <a:spcPct val="115000"/>
+              </a:lnSpc>
+              <a:spcAft>
+                <a:spcPts val="1000"/>
+              </a:spcAft>
+              <a:buSzPct val="100000"/>
+              <a:buChar char="•"/>
+            </a:pPr>
+            <a:r>
+              <a:rPr lang="en-US" sz="1900" dirty="0">
+                <a:solidFill>
+                  <a:srgbClr val="334155"/>
+                </a:solidFill>
+                <a:latin typeface="Segoe UI" pitchFamily="34" charset="0"/>
+                <a:ea typeface="Segoe UI" pitchFamily="34" charset="-122"/>
+                <a:cs typeface="Segoe UI" pitchFamily="34" charset="-120"/>
+              </a:rPr>
+              <a:t>Faltan herramientas sencillas que unifiquen el proceso con criterios de inclusividad.</a:t>
+            </a:r>
+            <a:endParaRPr lang="en-US" sz="1900" dirty="0"/>
+          </a:p>
+        </p:txBody>
+      </p:sp>
+      <p:sp>
+        <p:nvSpPr>
+          <p:cNvPr id="5" name="Shape 3"/>
+          <p:cNvSpPr/>
+          <p:nvPr/>
+        </p:nvSpPr>
+        <p:spPr>
+          <a:xfrm>
+            <a:off x="640080" y="6309360"/>
+            <a:ext cx="10908792" cy="0"/>
+          </a:xfrm>
+          <a:prstGeom prst="line">
+            <a:avLst/>
+          </a:prstGeom>
+          <a:noFill/>
+          <a:ln w="12700">
+            <a:solidFill>
+              <a:srgbClr val="E2E8F0"/>
+            </a:solidFill>
+            <a:prstDash val="solid"/>
+          </a:ln>
+        </p:spPr>
+      </p:sp>
+      <p:sp>
+        <p:nvSpPr>
+          <p:cNvPr id="6" name="Text 4"/>
           <p:cNvSpPr/>
           <p:nvPr/>
         </p:nvSpPr>
         <p:spPr>
           <a:xfrm>
             <a:off x="640080" y="6400800"/>
-            <a:ext cx="7315200" cy="274320"/>
+            <a:ext cx="8229600" cy="274320"/>
           </a:xfrm>
           <a:prstGeom prst="rect">
             <a:avLst/>
@@ -3037,7 +4650,7 @@
       </p:sp>
       <p:sp>
         <p:nvSpPr>
-          <p:cNvPr id="6" name="Text 4"/>
+          <p:cNvPr id="7" name="Text 5"/>
           <p:cNvSpPr/>
           <p:nvPr/>
         </p:nvSpPr>
@@ -3159,7 +4772,7 @@
                 <a:ea typeface="Segoe UI" pitchFamily="34" charset="-122"/>
                 <a:cs typeface="Segoe UI" pitchFamily="34" charset="-120"/>
               </a:rPr>
-              <a:t>La solución</a:t>
+              <a:t>La solución: RecruitKit</a:t>
             </a:r>
             <a:endParaRPr lang="en-US" sz="3000" dirty="0"/>
           </a:p>
@@ -3173,8 +4786,172 @@
         </p:nvSpPr>
         <p:spPr>
           <a:xfrm>
-            <a:off x="822960" y="1737360"/>
-            <a:ext cx="10515600" cy="4206240"/>
+            <a:off x="822960" y="1554480"/>
+            <a:ext cx="10515600" cy="548640"/>
+          </a:xfrm>
+          <a:prstGeom prst="rect">
+            <a:avLst/>
+          </a:prstGeom>
+          <a:noFill/>
+          <a:ln/>
+        </p:spPr>
+        <p:txBody>
+          <a:bodyPr wrap="square" rtlCol="0" anchor="ctr"/>
+          <a:lstStyle/>
+          <a:p>
+            <a:pPr indent="0" marL="0">
+              <a:buNone/>
+            </a:pPr>
+            <a:r>
+              <a:rPr lang="en-US" sz="1700" dirty="0">
+                <a:solidFill>
+                  <a:srgbClr val="334155"/>
+                </a:solidFill>
+                <a:latin typeface="Segoe UI" pitchFamily="34" charset="0"/>
+                <a:ea typeface="Segoe UI" pitchFamily="34" charset="-122"/>
+                <a:cs typeface="Segoe UI" pitchFamily="34" charset="-120"/>
+              </a:rPr>
+              <a:t>Un panel con varias herramientas que cubren el proceso de selección, con foco en la inclusividad.</a:t>
+            </a:r>
+            <a:endParaRPr lang="en-US" sz="1700" dirty="0"/>
+          </a:p>
+        </p:txBody>
+      </p:sp>
+      <p:sp>
+        <p:nvSpPr>
+          <p:cNvPr id="5" name="Shape 3"/>
+          <p:cNvSpPr/>
+          <p:nvPr/>
+        </p:nvSpPr>
+        <p:spPr>
+          <a:xfrm>
+            <a:off x="653796" y="2377440"/>
+            <a:ext cx="2514600" cy="2377440"/>
+          </a:xfrm>
+          <a:prstGeom prst="roundRect">
+            <a:avLst>
+              <a:gd name="adj" fmla="val 4615"/>
+            </a:avLst>
+          </a:prstGeom>
+          <a:solidFill>
+            <a:srgbClr val="F1F5F9"/>
+          </a:solidFill>
+          <a:ln w="12700">
+            <a:solidFill>
+              <a:srgbClr val="E2E8F0"/>
+            </a:solidFill>
+            <a:prstDash val="solid"/>
+          </a:ln>
+        </p:spPr>
+      </p:sp>
+      <p:sp>
+        <p:nvSpPr>
+          <p:cNvPr id="6" name="Shape 4"/>
+          <p:cNvSpPr/>
+          <p:nvPr/>
+        </p:nvSpPr>
+        <p:spPr>
+          <a:xfrm>
+            <a:off x="653796" y="2377440"/>
+            <a:ext cx="2514600" cy="109728"/>
+          </a:xfrm>
+          <a:prstGeom prst="rect">
+            <a:avLst/>
+          </a:prstGeom>
+          <a:solidFill>
+            <a:srgbClr val="4F46E5"/>
+          </a:solidFill>
+          <a:ln/>
+        </p:spPr>
+      </p:sp>
+      <p:sp>
+        <p:nvSpPr>
+          <p:cNvPr id="7" name="Text 5"/>
+          <p:cNvSpPr/>
+          <p:nvPr/>
+        </p:nvSpPr>
+        <p:spPr>
+          <a:xfrm>
+            <a:off x="653796" y="2606040"/>
+            <a:ext cx="2514600" cy="640080"/>
+          </a:xfrm>
+          <a:prstGeom prst="rect">
+            <a:avLst/>
+          </a:prstGeom>
+          <a:noFill/>
+          <a:ln/>
+        </p:spPr>
+        <p:txBody>
+          <a:bodyPr wrap="square" rtlCol="0" anchor="ctr"/>
+          <a:lstStyle/>
+          <a:p>
+            <a:pPr algn="ctr" indent="0" marL="0">
+              <a:buNone/>
+            </a:pPr>
+            <a:r>
+              <a:rPr lang="en-US" sz="3000" dirty="0">
+                <a:solidFill>
+                  <a:srgbClr val="000000"/>
+                </a:solidFill>
+                <a:latin typeface="Segoe UI Emoji" pitchFamily="34" charset="0"/>
+                <a:ea typeface="Segoe UI Emoji" pitchFamily="34" charset="-122"/>
+                <a:cs typeface="Segoe UI Emoji" pitchFamily="34" charset="-120"/>
+              </a:rPr>
+              <a:t>⚖️</a:t>
+            </a:r>
+            <a:endParaRPr lang="en-US" sz="3000" dirty="0"/>
+          </a:p>
+        </p:txBody>
+      </p:sp>
+      <p:sp>
+        <p:nvSpPr>
+          <p:cNvPr id="8" name="Text 6"/>
+          <p:cNvSpPr/>
+          <p:nvPr/>
+        </p:nvSpPr>
+        <p:spPr>
+          <a:xfrm>
+            <a:off x="653796" y="3337560"/>
+            <a:ext cx="2514600" cy="365760"/>
+          </a:xfrm>
+          <a:prstGeom prst="rect">
+            <a:avLst/>
+          </a:prstGeom>
+          <a:noFill/>
+          <a:ln/>
+        </p:spPr>
+        <p:txBody>
+          <a:bodyPr wrap="square" rtlCol="0" anchor="ctr"/>
+          <a:lstStyle/>
+          <a:p>
+            <a:pPr algn="ctr" indent="0" marL="0">
+              <a:buNone/>
+            </a:pPr>
+            <a:r>
+              <a:rPr lang="en-US" sz="1700" b="1" dirty="0">
+                <a:solidFill>
+                  <a:srgbClr val="0F172A"/>
+                </a:solidFill>
+                <a:latin typeface="Segoe UI" pitchFamily="34" charset="0"/>
+                <a:ea typeface="Segoe UI" pitchFamily="34" charset="-122"/>
+                <a:cs typeface="Segoe UI" pitchFamily="34" charset="-120"/>
+              </a:rPr>
+              <a:t>Más justo</a:t>
+            </a:r>
+            <a:endParaRPr lang="en-US" sz="1700" dirty="0"/>
+          </a:p>
+        </p:txBody>
+      </p:sp>
+      <p:sp>
+        <p:nvSpPr>
+          <p:cNvPr id="9" name="Text 7"/>
+          <p:cNvSpPr/>
+          <p:nvPr/>
+        </p:nvSpPr>
+        <p:spPr>
+          <a:xfrm>
+            <a:off x="836676" y="3749040"/>
+            <a:ext cx="2148840" cy="822960"/>
           </a:xfrm>
           <a:prstGeom prst="rect">
             <a:avLst/>
@@ -3186,113 +4963,549 @@
           <a:bodyPr wrap="square" rtlCol="0" anchor="t"/>
           <a:lstStyle/>
           <a:p>
-            <a:pPr marL="228600" indent="-228600">
-              <a:lnSpc>
-                <a:spcPct val="115000"/>
-              </a:lnSpc>
-              <a:spcAft>
-                <a:spcPts val="1000"/>
-              </a:spcAft>
-              <a:buSzPct val="100000"/>
-              <a:buChar char="•"/>
-            </a:pPr>
-            <a:r>
-              <a:rPr lang="en-US" sz="1900" dirty="0">
-                <a:solidFill>
-                  <a:srgbClr val="334155"/>
-                </a:solidFill>
-                <a:latin typeface="Segoe UI" pitchFamily="34" charset="0"/>
-                <a:ea typeface="Segoe UI" pitchFamily="34" charset="-122"/>
-                <a:cs typeface="Segoe UI" pitchFamily="34" charset="-120"/>
-              </a:rPr>
-              <a:t>RecruitKit: un panel con varias herramientas que cubren el proceso de selección, con foco en la inclusividad.</a:t>
-            </a:r>
-            <a:endParaRPr lang="en-US" sz="1900" dirty="0"/>
-          </a:p>
-          <a:p>
-            <a:pPr marL="228600" indent="-228600">
-              <a:lnSpc>
-                <a:spcPct val="115000"/>
-              </a:lnSpc>
-              <a:spcAft>
-                <a:spcPts val="1000"/>
-              </a:spcAft>
-              <a:buSzPct val="100000"/>
-              <a:buChar char="•"/>
-            </a:pPr>
-            <a:r>
-              <a:rPr lang="en-US" sz="1900" dirty="0">
-                <a:solidFill>
-                  <a:srgbClr val="334155"/>
-                </a:solidFill>
-                <a:latin typeface="Segoe UI" pitchFamily="34" charset="0"/>
-                <a:ea typeface="Segoe UI" pitchFamily="34" charset="-122"/>
-                <a:cs typeface="Segoe UI" pitchFamily="34" charset="-120"/>
-              </a:rPr>
-              <a:t>Análisis local y determinista, con IA opcional.</a:t>
-            </a:r>
-            <a:endParaRPr lang="en-US" sz="1900" dirty="0"/>
-          </a:p>
-          <a:p>
-            <a:pPr marL="228600" indent="-228600">
-              <a:lnSpc>
-                <a:spcPct val="115000"/>
-              </a:lnSpc>
-              <a:spcAft>
-                <a:spcPts val="1000"/>
-              </a:spcAft>
-              <a:buSzPct val="100000"/>
-              <a:buChar char="•"/>
-            </a:pPr>
-            <a:r>
-              <a:rPr lang="en-US" sz="1900" dirty="0">
-                <a:solidFill>
-                  <a:srgbClr val="334155"/>
-                </a:solidFill>
-                <a:latin typeface="Segoe UI" pitchFamily="34" charset="0"/>
-                <a:ea typeface="Segoe UI" pitchFamily="34" charset="-122"/>
-                <a:cs typeface="Segoe UI" pitchFamily="34" charset="-120"/>
-              </a:rPr>
-              <a:t>Interfaz en español e inglés.</a:t>
-            </a:r>
-            <a:endParaRPr lang="en-US" sz="1900" dirty="0"/>
-          </a:p>
-          <a:p>
-            <a:pPr marL="228600" indent="-228600">
-              <a:lnSpc>
-                <a:spcPct val="115000"/>
-              </a:lnSpc>
-              <a:spcAft>
-                <a:spcPts val="1000"/>
-              </a:spcAft>
-              <a:buSzPct val="100000"/>
-              <a:buChar char="•"/>
-            </a:pPr>
-            <a:r>
-              <a:rPr lang="en-US" sz="1900" dirty="0">
-                <a:solidFill>
-                  <a:srgbClr val="334155"/>
-                </a:solidFill>
-                <a:latin typeface="Segoe UI" pitchFamily="34" charset="0"/>
-                <a:ea typeface="Segoe UI" pitchFamily="34" charset="-122"/>
-                <a:cs typeface="Segoe UI" pitchFamily="34" charset="-120"/>
-              </a:rPr>
-              <a:t>Desplegable gratis, sin infraestructura obligatoria.</a:t>
-            </a:r>
-            <a:endParaRPr lang="en-US" sz="1900" dirty="0"/>
-          </a:p>
-        </p:txBody>
-      </p:sp>
-      <p:sp>
-        <p:nvSpPr>
-          <p:cNvPr id="5" name="Text 3"/>
+            <a:pPr algn="ctr" indent="0" marL="0">
+              <a:buNone/>
+            </a:pPr>
+            <a:r>
+              <a:rPr lang="en-US" sz="1250" dirty="0">
+                <a:solidFill>
+                  <a:srgbClr val="64748B"/>
+                </a:solidFill>
+                <a:latin typeface="Segoe UI" pitchFamily="34" charset="0"/>
+                <a:ea typeface="Segoe UI" pitchFamily="34" charset="-122"/>
+                <a:cs typeface="Segoe UI" pitchFamily="34" charset="-120"/>
+              </a:rPr>
+              <a:t>Detecta y corrige sesgos; fomenta la diversidad.</a:t>
+            </a:r>
+            <a:endParaRPr lang="en-US" sz="1250" dirty="0"/>
+          </a:p>
+        </p:txBody>
+      </p:sp>
+      <p:sp>
+        <p:nvSpPr>
+          <p:cNvPr id="10" name="Shape 8"/>
+          <p:cNvSpPr/>
+          <p:nvPr/>
+        </p:nvSpPr>
+        <p:spPr>
+          <a:xfrm>
+            <a:off x="3442716" y="2377440"/>
+            <a:ext cx="2514600" cy="2377440"/>
+          </a:xfrm>
+          <a:prstGeom prst="roundRect">
+            <a:avLst>
+              <a:gd name="adj" fmla="val 4615"/>
+            </a:avLst>
+          </a:prstGeom>
+          <a:solidFill>
+            <a:srgbClr val="F1F5F9"/>
+          </a:solidFill>
+          <a:ln w="12700">
+            <a:solidFill>
+              <a:srgbClr val="E2E8F0"/>
+            </a:solidFill>
+            <a:prstDash val="solid"/>
+          </a:ln>
+        </p:spPr>
+      </p:sp>
+      <p:sp>
+        <p:nvSpPr>
+          <p:cNvPr id="11" name="Shape 9"/>
+          <p:cNvSpPr/>
+          <p:nvPr/>
+        </p:nvSpPr>
+        <p:spPr>
+          <a:xfrm>
+            <a:off x="3442716" y="2377440"/>
+            <a:ext cx="2514600" cy="109728"/>
+          </a:xfrm>
+          <a:prstGeom prst="rect">
+            <a:avLst/>
+          </a:prstGeom>
+          <a:solidFill>
+            <a:srgbClr val="8B5CF6"/>
+          </a:solidFill>
+          <a:ln/>
+        </p:spPr>
+      </p:sp>
+      <p:sp>
+        <p:nvSpPr>
+          <p:cNvPr id="12" name="Text 10"/>
+          <p:cNvSpPr/>
+          <p:nvPr/>
+        </p:nvSpPr>
+        <p:spPr>
+          <a:xfrm>
+            <a:off x="3442716" y="2606040"/>
+            <a:ext cx="2514600" cy="640080"/>
+          </a:xfrm>
+          <a:prstGeom prst="rect">
+            <a:avLst/>
+          </a:prstGeom>
+          <a:noFill/>
+          <a:ln/>
+        </p:spPr>
+        <p:txBody>
+          <a:bodyPr wrap="square" rtlCol="0" anchor="ctr"/>
+          <a:lstStyle/>
+          <a:p>
+            <a:pPr algn="ctr" indent="0" marL="0">
+              <a:buNone/>
+            </a:pPr>
+            <a:r>
+              <a:rPr lang="en-US" sz="3000" dirty="0">
+                <a:solidFill>
+                  <a:srgbClr val="000000"/>
+                </a:solidFill>
+                <a:latin typeface="Segoe UI Emoji" pitchFamily="34" charset="0"/>
+                <a:ea typeface="Segoe UI Emoji" pitchFamily="34" charset="-122"/>
+                <a:cs typeface="Segoe UI Emoji" pitchFamily="34" charset="-120"/>
+              </a:rPr>
+              <a:t>⏱️</a:t>
+            </a:r>
+            <a:endParaRPr lang="en-US" sz="3000" dirty="0"/>
+          </a:p>
+        </p:txBody>
+      </p:sp>
+      <p:sp>
+        <p:nvSpPr>
+          <p:cNvPr id="13" name="Text 11"/>
+          <p:cNvSpPr/>
+          <p:nvPr/>
+        </p:nvSpPr>
+        <p:spPr>
+          <a:xfrm>
+            <a:off x="3442716" y="3337560"/>
+            <a:ext cx="2514600" cy="365760"/>
+          </a:xfrm>
+          <a:prstGeom prst="rect">
+            <a:avLst/>
+          </a:prstGeom>
+          <a:noFill/>
+          <a:ln/>
+        </p:spPr>
+        <p:txBody>
+          <a:bodyPr wrap="square" rtlCol="0" anchor="ctr"/>
+          <a:lstStyle/>
+          <a:p>
+            <a:pPr algn="ctr" indent="0" marL="0">
+              <a:buNone/>
+            </a:pPr>
+            <a:r>
+              <a:rPr lang="en-US" sz="1700" b="1" dirty="0">
+                <a:solidFill>
+                  <a:srgbClr val="0F172A"/>
+                </a:solidFill>
+                <a:latin typeface="Segoe UI" pitchFamily="34" charset="0"/>
+                <a:ea typeface="Segoe UI" pitchFamily="34" charset="-122"/>
+                <a:cs typeface="Segoe UI" pitchFamily="34" charset="-120"/>
+              </a:rPr>
+              <a:t>Más eficaz</a:t>
+            </a:r>
+            <a:endParaRPr lang="en-US" sz="1700" dirty="0"/>
+          </a:p>
+        </p:txBody>
+      </p:sp>
+      <p:sp>
+        <p:nvSpPr>
+          <p:cNvPr id="14" name="Text 12"/>
+          <p:cNvSpPr/>
+          <p:nvPr/>
+        </p:nvSpPr>
+        <p:spPr>
+          <a:xfrm>
+            <a:off x="3625596" y="3749040"/>
+            <a:ext cx="2148840" cy="822960"/>
+          </a:xfrm>
+          <a:prstGeom prst="rect">
+            <a:avLst/>
+          </a:prstGeom>
+          <a:noFill/>
+          <a:ln/>
+        </p:spPr>
+        <p:txBody>
+          <a:bodyPr wrap="square" rtlCol="0" anchor="t"/>
+          <a:lstStyle/>
+          <a:p>
+            <a:pPr algn="ctr" indent="0" marL="0">
+              <a:buNone/>
+            </a:pPr>
+            <a:r>
+              <a:rPr lang="en-US" sz="1250" dirty="0">
+                <a:solidFill>
+                  <a:srgbClr val="64748B"/>
+                </a:solidFill>
+                <a:latin typeface="Segoe UI" pitchFamily="34" charset="0"/>
+                <a:ea typeface="Segoe UI" pitchFamily="34" charset="-122"/>
+                <a:cs typeface="Segoe UI" pitchFamily="34" charset="-120"/>
+              </a:rPr>
+              <a:t>Redacta, filtra y comunica en menos tiempo.</a:t>
+            </a:r>
+            <a:endParaRPr lang="en-US" sz="1250" dirty="0"/>
+          </a:p>
+        </p:txBody>
+      </p:sp>
+      <p:sp>
+        <p:nvSpPr>
+          <p:cNvPr id="15" name="Shape 13"/>
+          <p:cNvSpPr/>
+          <p:nvPr/>
+        </p:nvSpPr>
+        <p:spPr>
+          <a:xfrm>
+            <a:off x="6231636" y="2377440"/>
+            <a:ext cx="2514600" cy="2377440"/>
+          </a:xfrm>
+          <a:prstGeom prst="roundRect">
+            <a:avLst>
+              <a:gd name="adj" fmla="val 4615"/>
+            </a:avLst>
+          </a:prstGeom>
+          <a:solidFill>
+            <a:srgbClr val="F1F5F9"/>
+          </a:solidFill>
+          <a:ln w="12700">
+            <a:solidFill>
+              <a:srgbClr val="E2E8F0"/>
+            </a:solidFill>
+            <a:prstDash val="solid"/>
+          </a:ln>
+        </p:spPr>
+      </p:sp>
+      <p:sp>
+        <p:nvSpPr>
+          <p:cNvPr id="16" name="Shape 14"/>
+          <p:cNvSpPr/>
+          <p:nvPr/>
+        </p:nvSpPr>
+        <p:spPr>
+          <a:xfrm>
+            <a:off x="6231636" y="2377440"/>
+            <a:ext cx="2514600" cy="109728"/>
+          </a:xfrm>
+          <a:prstGeom prst="rect">
+            <a:avLst/>
+          </a:prstGeom>
+          <a:solidFill>
+            <a:srgbClr val="14B8A6"/>
+          </a:solidFill>
+          <a:ln/>
+        </p:spPr>
+      </p:sp>
+      <p:sp>
+        <p:nvSpPr>
+          <p:cNvPr id="17" name="Text 15"/>
+          <p:cNvSpPr/>
+          <p:nvPr/>
+        </p:nvSpPr>
+        <p:spPr>
+          <a:xfrm>
+            <a:off x="6231636" y="2606040"/>
+            <a:ext cx="2514600" cy="640080"/>
+          </a:xfrm>
+          <a:prstGeom prst="rect">
+            <a:avLst/>
+          </a:prstGeom>
+          <a:noFill/>
+          <a:ln/>
+        </p:spPr>
+        <p:txBody>
+          <a:bodyPr wrap="square" rtlCol="0" anchor="ctr"/>
+          <a:lstStyle/>
+          <a:p>
+            <a:pPr algn="ctr" indent="0" marL="0">
+              <a:buNone/>
+            </a:pPr>
+            <a:r>
+              <a:rPr lang="en-US" sz="3000" dirty="0">
+                <a:solidFill>
+                  <a:srgbClr val="000000"/>
+                </a:solidFill>
+                <a:latin typeface="Segoe UI Emoji" pitchFamily="34" charset="0"/>
+                <a:ea typeface="Segoe UI Emoji" pitchFamily="34" charset="-122"/>
+                <a:cs typeface="Segoe UI Emoji" pitchFamily="34" charset="-120"/>
+              </a:rPr>
+              <a:t>🔒</a:t>
+            </a:r>
+            <a:endParaRPr lang="en-US" sz="3000" dirty="0"/>
+          </a:p>
+        </p:txBody>
+      </p:sp>
+      <p:sp>
+        <p:nvSpPr>
+          <p:cNvPr id="18" name="Text 16"/>
+          <p:cNvSpPr/>
+          <p:nvPr/>
+        </p:nvSpPr>
+        <p:spPr>
+          <a:xfrm>
+            <a:off x="6231636" y="3337560"/>
+            <a:ext cx="2514600" cy="365760"/>
+          </a:xfrm>
+          <a:prstGeom prst="rect">
+            <a:avLst/>
+          </a:prstGeom>
+          <a:noFill/>
+          <a:ln/>
+        </p:spPr>
+        <p:txBody>
+          <a:bodyPr wrap="square" rtlCol="0" anchor="ctr"/>
+          <a:lstStyle/>
+          <a:p>
+            <a:pPr algn="ctr" indent="0" marL="0">
+              <a:buNone/>
+            </a:pPr>
+            <a:r>
+              <a:rPr lang="en-US" sz="1700" b="1" dirty="0">
+                <a:solidFill>
+                  <a:srgbClr val="0F172A"/>
+                </a:solidFill>
+                <a:latin typeface="Segoe UI" pitchFamily="34" charset="0"/>
+                <a:ea typeface="Segoe UI" pitchFamily="34" charset="-122"/>
+                <a:cs typeface="Segoe UI" pitchFamily="34" charset="-120"/>
+              </a:rPr>
+              <a:t>Sin ataduras</a:t>
+            </a:r>
+            <a:endParaRPr lang="en-US" sz="1700" dirty="0"/>
+          </a:p>
+        </p:txBody>
+      </p:sp>
+      <p:sp>
+        <p:nvSpPr>
+          <p:cNvPr id="19" name="Text 17"/>
+          <p:cNvSpPr/>
+          <p:nvPr/>
+        </p:nvSpPr>
+        <p:spPr>
+          <a:xfrm>
+            <a:off x="6414516" y="3749040"/>
+            <a:ext cx="2148840" cy="822960"/>
+          </a:xfrm>
+          <a:prstGeom prst="rect">
+            <a:avLst/>
+          </a:prstGeom>
+          <a:noFill/>
+          <a:ln/>
+        </p:spPr>
+        <p:txBody>
+          <a:bodyPr wrap="square" rtlCol="0" anchor="t"/>
+          <a:lstStyle/>
+          <a:p>
+            <a:pPr algn="ctr" indent="0" marL="0">
+              <a:buNone/>
+            </a:pPr>
+            <a:r>
+              <a:rPr lang="en-US" sz="1250" dirty="0">
+                <a:solidFill>
+                  <a:srgbClr val="64748B"/>
+                </a:solidFill>
+                <a:latin typeface="Segoe UI" pitchFamily="34" charset="0"/>
+                <a:ea typeface="Segoe UI" pitchFamily="34" charset="-122"/>
+                <a:cs typeface="Segoe UI" pitchFamily="34" charset="-120"/>
+              </a:rPr>
+              <a:t>Funciona con o sin base de datos y con IA opcional.</a:t>
+            </a:r>
+            <a:endParaRPr lang="en-US" sz="1250" dirty="0"/>
+          </a:p>
+        </p:txBody>
+      </p:sp>
+      <p:sp>
+        <p:nvSpPr>
+          <p:cNvPr id="20" name="Shape 18"/>
+          <p:cNvSpPr/>
+          <p:nvPr/>
+        </p:nvSpPr>
+        <p:spPr>
+          <a:xfrm>
+            <a:off x="9020556" y="2377440"/>
+            <a:ext cx="2514600" cy="2377440"/>
+          </a:xfrm>
+          <a:prstGeom prst="roundRect">
+            <a:avLst>
+              <a:gd name="adj" fmla="val 4615"/>
+            </a:avLst>
+          </a:prstGeom>
+          <a:solidFill>
+            <a:srgbClr val="F1F5F9"/>
+          </a:solidFill>
+          <a:ln w="12700">
+            <a:solidFill>
+              <a:srgbClr val="E2E8F0"/>
+            </a:solidFill>
+            <a:prstDash val="solid"/>
+          </a:ln>
+        </p:spPr>
+      </p:sp>
+      <p:sp>
+        <p:nvSpPr>
+          <p:cNvPr id="21" name="Shape 19"/>
+          <p:cNvSpPr/>
+          <p:nvPr/>
+        </p:nvSpPr>
+        <p:spPr>
+          <a:xfrm>
+            <a:off x="9020556" y="2377440"/>
+            <a:ext cx="2514600" cy="109728"/>
+          </a:xfrm>
+          <a:prstGeom prst="rect">
+            <a:avLst/>
+          </a:prstGeom>
+          <a:solidFill>
+            <a:srgbClr val="EC4899"/>
+          </a:solidFill>
+          <a:ln/>
+        </p:spPr>
+      </p:sp>
+      <p:sp>
+        <p:nvSpPr>
+          <p:cNvPr id="22" name="Text 20"/>
+          <p:cNvSpPr/>
+          <p:nvPr/>
+        </p:nvSpPr>
+        <p:spPr>
+          <a:xfrm>
+            <a:off x="9020556" y="2606040"/>
+            <a:ext cx="2514600" cy="640080"/>
+          </a:xfrm>
+          <a:prstGeom prst="rect">
+            <a:avLst/>
+          </a:prstGeom>
+          <a:noFill/>
+          <a:ln/>
+        </p:spPr>
+        <p:txBody>
+          <a:bodyPr wrap="square" rtlCol="0" anchor="ctr"/>
+          <a:lstStyle/>
+          <a:p>
+            <a:pPr algn="ctr" indent="0" marL="0">
+              <a:buNone/>
+            </a:pPr>
+            <a:r>
+              <a:rPr lang="en-US" sz="3000" dirty="0">
+                <a:solidFill>
+                  <a:srgbClr val="000000"/>
+                </a:solidFill>
+                <a:latin typeface="Segoe UI Emoji" pitchFamily="34" charset="0"/>
+                <a:ea typeface="Segoe UI Emoji" pitchFamily="34" charset="-122"/>
+                <a:cs typeface="Segoe UI Emoji" pitchFamily="34" charset="-120"/>
+              </a:rPr>
+              <a:t>🌍</a:t>
+            </a:r>
+            <a:endParaRPr lang="en-US" sz="3000" dirty="0"/>
+          </a:p>
+        </p:txBody>
+      </p:sp>
+      <p:sp>
+        <p:nvSpPr>
+          <p:cNvPr id="23" name="Text 21"/>
+          <p:cNvSpPr/>
+          <p:nvPr/>
+        </p:nvSpPr>
+        <p:spPr>
+          <a:xfrm>
+            <a:off x="9020556" y="3337560"/>
+            <a:ext cx="2514600" cy="365760"/>
+          </a:xfrm>
+          <a:prstGeom prst="rect">
+            <a:avLst/>
+          </a:prstGeom>
+          <a:noFill/>
+          <a:ln/>
+        </p:spPr>
+        <p:txBody>
+          <a:bodyPr wrap="square" rtlCol="0" anchor="ctr"/>
+          <a:lstStyle/>
+          <a:p>
+            <a:pPr algn="ctr" indent="0" marL="0">
+              <a:buNone/>
+            </a:pPr>
+            <a:r>
+              <a:rPr lang="en-US" sz="1700" b="1" dirty="0">
+                <a:solidFill>
+                  <a:srgbClr val="0F172A"/>
+                </a:solidFill>
+                <a:latin typeface="Segoe UI" pitchFamily="34" charset="0"/>
+                <a:ea typeface="Segoe UI" pitchFamily="34" charset="-122"/>
+                <a:cs typeface="Segoe UI" pitchFamily="34" charset="-120"/>
+              </a:rPr>
+              <a:t>Accesible</a:t>
+            </a:r>
+            <a:endParaRPr lang="en-US" sz="1700" dirty="0"/>
+          </a:p>
+        </p:txBody>
+      </p:sp>
+      <p:sp>
+        <p:nvSpPr>
+          <p:cNvPr id="24" name="Text 22"/>
+          <p:cNvSpPr/>
+          <p:nvPr/>
+        </p:nvSpPr>
+        <p:spPr>
+          <a:xfrm>
+            <a:off x="9203436" y="3749040"/>
+            <a:ext cx="2148840" cy="822960"/>
+          </a:xfrm>
+          <a:prstGeom prst="rect">
+            <a:avLst/>
+          </a:prstGeom>
+          <a:noFill/>
+          <a:ln/>
+        </p:spPr>
+        <p:txBody>
+          <a:bodyPr wrap="square" rtlCol="0" anchor="t"/>
+          <a:lstStyle/>
+          <a:p>
+            <a:pPr algn="ctr" indent="0" marL="0">
+              <a:buNone/>
+            </a:pPr>
+            <a:r>
+              <a:rPr lang="en-US" sz="1250" dirty="0">
+                <a:solidFill>
+                  <a:srgbClr val="64748B"/>
+                </a:solidFill>
+                <a:latin typeface="Segoe UI" pitchFamily="34" charset="0"/>
+                <a:ea typeface="Segoe UI" pitchFamily="34" charset="-122"/>
+                <a:cs typeface="Segoe UI" pitchFamily="34" charset="-120"/>
+              </a:rPr>
+              <a:t>Español e inglés, claro/oscuro, desplegado gratis.</a:t>
+            </a:r>
+            <a:endParaRPr lang="en-US" sz="1250" dirty="0"/>
+          </a:p>
+        </p:txBody>
+      </p:sp>
+      <p:sp>
+        <p:nvSpPr>
+          <p:cNvPr id="25" name="Shape 23"/>
+          <p:cNvSpPr/>
+          <p:nvPr/>
+        </p:nvSpPr>
+        <p:spPr>
+          <a:xfrm>
+            <a:off x="640080" y="6309360"/>
+            <a:ext cx="10908792" cy="0"/>
+          </a:xfrm>
+          <a:prstGeom prst="line">
+            <a:avLst/>
+          </a:prstGeom>
+          <a:noFill/>
+          <a:ln w="12700">
+            <a:solidFill>
+              <a:srgbClr val="E2E8F0"/>
+            </a:solidFill>
+            <a:prstDash val="solid"/>
+          </a:ln>
+        </p:spPr>
+      </p:sp>
+      <p:sp>
+        <p:nvSpPr>
+          <p:cNvPr id="26" name="Text 24"/>
           <p:cNvSpPr/>
           <p:nvPr/>
         </p:nvSpPr>
         <p:spPr>
           <a:xfrm>
             <a:off x="640080" y="6400800"/>
-            <a:ext cx="7315200" cy="274320"/>
+            <a:ext cx="8229600" cy="274320"/>
           </a:xfrm>
           <a:prstGeom prst="rect">
             <a:avLst/>
@@ -3324,7 +5537,7 @@
       </p:sp>
       <p:sp>
         <p:nvSpPr>
-          <p:cNvPr id="6" name="Text 4"/>
+          <p:cNvPr id="27" name="Text 25"/>
           <p:cNvSpPr/>
           <p:nvPr/>
         </p:nvSpPr>
@@ -3520,7 +5733,7 @@
           <a:bodyPr wrap="square" rtlCol="0" anchor="ctr"/>
           <a:lstStyle/>
           <a:p>
-            <a:pPr algn="l" indent="0" marL="0">
+            <a:pPr indent="0" marL="0">
               <a:buNone/>
             </a:pPr>
             <a:r>
@@ -3645,7 +5858,7 @@
           <a:bodyPr wrap="square" rtlCol="0" anchor="ctr"/>
           <a:lstStyle/>
           <a:p>
-            <a:pPr algn="l" indent="0" marL="0">
+            <a:pPr indent="0" marL="0">
               <a:buNone/>
             </a:pPr>
             <a:r>
@@ -3770,7 +5983,7 @@
           <a:bodyPr wrap="square" rtlCol="0" anchor="ctr"/>
           <a:lstStyle/>
           <a:p>
-            <a:pPr algn="l" indent="0" marL="0">
+            <a:pPr indent="0" marL="0">
               <a:buNone/>
             </a:pPr>
             <a:r>
@@ -3895,7 +6108,7 @@
           <a:bodyPr wrap="square" rtlCol="0" anchor="ctr"/>
           <a:lstStyle/>
           <a:p>
-            <a:pPr algn="l" indent="0" marL="0">
+            <a:pPr indent="0" marL="0">
               <a:buNone/>
             </a:pPr>
             <a:r>
@@ -4020,7 +6233,7 @@
           <a:bodyPr wrap="square" rtlCol="0" anchor="ctr"/>
           <a:lstStyle/>
           <a:p>
-            <a:pPr algn="l" indent="0" marL="0">
+            <a:pPr indent="0" marL="0">
               <a:buNone/>
             </a:pPr>
             <a:r>
@@ -4145,7 +6358,7 @@
           <a:bodyPr wrap="square" rtlCol="0" anchor="ctr"/>
           <a:lstStyle/>
           <a:p>
-            <a:pPr algn="l" indent="0" marL="0">
+            <a:pPr indent="0" marL="0">
               <a:buNone/>
             </a:pPr>
             <a:r>
@@ -4270,7 +6483,7 @@
           <a:bodyPr wrap="square" rtlCol="0" anchor="ctr"/>
           <a:lstStyle/>
           <a:p>
-            <a:pPr algn="l" indent="0" marL="0">
+            <a:pPr indent="0" marL="0">
               <a:buNone/>
             </a:pPr>
             <a:r>
@@ -4395,7 +6608,7 @@
           <a:bodyPr wrap="square" rtlCol="0" anchor="ctr"/>
           <a:lstStyle/>
           <a:p>
-            <a:pPr algn="l" indent="0" marL="0">
+            <a:pPr indent="0" marL="0">
               <a:buNone/>
             </a:pPr>
             <a:r>
@@ -4454,14 +6667,37 @@
       </p:sp>
       <p:sp>
         <p:nvSpPr>
-          <p:cNvPr id="36" name="Text 34"/>
+          <p:cNvPr id="36" name="Shape 34"/>
+          <p:cNvSpPr/>
+          <p:nvPr/>
+        </p:nvSpPr>
+        <p:spPr>
+          <a:xfrm>
+            <a:off x="640080" y="6309360"/>
+            <a:ext cx="10908792" cy="0"/>
+          </a:xfrm>
+          <a:prstGeom prst="line">
+            <a:avLst/>
+          </a:prstGeom>
+          <a:noFill/>
+          <a:ln w="12700">
+            <a:solidFill>
+              <a:srgbClr val="E2E8F0"/>
+            </a:solidFill>
+            <a:prstDash val="solid"/>
+          </a:ln>
+        </p:spPr>
+      </p:sp>
+      <p:sp>
+        <p:nvSpPr>
+          <p:cNvPr id="37" name="Text 35"/>
           <p:cNvSpPr/>
           <p:nvPr/>
         </p:nvSpPr>
         <p:spPr>
           <a:xfrm>
             <a:off x="640080" y="6400800"/>
-            <a:ext cx="7315200" cy="274320"/>
+            <a:ext cx="8229600" cy="274320"/>
           </a:xfrm>
           <a:prstGeom prst="rect">
             <a:avLst/>
@@ -4493,7 +6729,7 @@
       </p:sp>
       <p:sp>
         <p:nvSpPr>
-          <p:cNvPr id="37" name="Text 35"/>
+          <p:cNvPr id="38" name="Text 36"/>
           <p:cNvSpPr/>
           <p:nvPr/>
         </p:nvSpPr>
@@ -4630,7 +6866,7 @@
         <p:spPr>
           <a:xfrm>
             <a:off x="822960" y="1737360"/>
-            <a:ext cx="10515600" cy="4206240"/>
+            <a:ext cx="10515600" cy="4023360"/>
           </a:xfrm>
           <a:prstGeom prst="rect">
             <a:avLst/>
@@ -4685,7 +6921,7 @@
                 <a:ea typeface="Segoe UI" pitchFamily="34" charset="-122"/>
                 <a:cs typeface="Segoe UI" pitchFamily="34" charset="-120"/>
               </a:rPr>
-              <a:t>Índice de inclusividad de 0 a 100.</a:t>
+              <a:t>Índice de inclusividad de 0 a 100 y detección de buenas prácticas.</a:t>
             </a:r>
             <a:endParaRPr lang="en-US" sz="1900" dirty="0"/>
           </a:p>
@@ -4709,7 +6945,7 @@
                 <a:ea typeface="Segoe UI" pitchFamily="34" charset="-122"/>
                 <a:cs typeface="Segoe UI" pitchFamily="34" charset="-120"/>
               </a:rPr>
-              <a:t>Detección de buenas prácticas: salario, flexibilidad, igualdad…</a:t>
+              <a:t>Reescritura: aplica las sugerencias una a una, toda de golpe o con IA.</a:t>
             </a:r>
             <a:endParaRPr lang="en-US" sz="1900" dirty="0"/>
           </a:p>
@@ -4733,7 +6969,7 @@
                 <a:ea typeface="Segoe UI" pitchFamily="34" charset="-122"/>
                 <a:cs typeface="Segoe UI" pitchFamily="34" charset="-120"/>
               </a:rPr>
-              <a:t>Reescritura: aplica las sugerencias una a una o toda de golpe.</a:t>
+              <a:t>Exporta un informe profesional en Word o PDF.</a:t>
             </a:r>
             <a:endParaRPr lang="en-US" sz="1900" dirty="0"/>
           </a:p>
@@ -4741,14 +6977,37 @@
       </p:sp>
       <p:sp>
         <p:nvSpPr>
-          <p:cNvPr id="5" name="Text 3"/>
+          <p:cNvPr id="5" name="Shape 3"/>
+          <p:cNvSpPr/>
+          <p:nvPr/>
+        </p:nvSpPr>
+        <p:spPr>
+          <a:xfrm>
+            <a:off x="640080" y="6309360"/>
+            <a:ext cx="10908792" cy="0"/>
+          </a:xfrm>
+          <a:prstGeom prst="line">
+            <a:avLst/>
+          </a:prstGeom>
+          <a:noFill/>
+          <a:ln w="12700">
+            <a:solidFill>
+              <a:srgbClr val="E2E8F0"/>
+            </a:solidFill>
+            <a:prstDash val="solid"/>
+          </a:ln>
+        </p:spPr>
+      </p:sp>
+      <p:sp>
+        <p:nvSpPr>
+          <p:cNvPr id="6" name="Text 4"/>
           <p:cNvSpPr/>
           <p:nvPr/>
         </p:nvSpPr>
         <p:spPr>
           <a:xfrm>
             <a:off x="640080" y="6400800"/>
-            <a:ext cx="7315200" cy="274320"/>
+            <a:ext cx="8229600" cy="274320"/>
           </a:xfrm>
           <a:prstGeom prst="rect">
             <a:avLst/>
@@ -4780,7 +7039,7 @@
       </p:sp>
       <p:sp>
         <p:nvSpPr>
-          <p:cNvPr id="6" name="Text 4"/>
+          <p:cNvPr id="7" name="Text 5"/>
           <p:cNvSpPr/>
           <p:nvPr/>
         </p:nvSpPr>
@@ -4902,7 +7161,7 @@
                 <a:ea typeface="Segoe UI" pitchFamily="34" charset="-122"/>
                 <a:cs typeface="Segoe UI" pitchFamily="34" charset="-120"/>
               </a:rPr>
-              <a:t>Reescritura con IA (opcional)</a:t>
+              <a:t>Funciones potenciadas por IA</a:t>
             </a:r>
             <a:endParaRPr lang="en-US" sz="3000" dirty="0"/>
           </a:p>
@@ -4916,8 +7175,152 @@
         </p:nvSpPr>
         <p:spPr>
           <a:xfrm>
-            <a:off x="822960" y="1737360"/>
-            <a:ext cx="10515600" cy="4206240"/>
+            <a:off x="822960" y="1508760"/>
+            <a:ext cx="10515600" cy="457200"/>
+          </a:xfrm>
+          <a:prstGeom prst="rect">
+            <a:avLst/>
+          </a:prstGeom>
+          <a:noFill/>
+          <a:ln/>
+        </p:spPr>
+        <p:txBody>
+          <a:bodyPr wrap="square" rtlCol="0" anchor="ctr"/>
+          <a:lstStyle/>
+          <a:p>
+            <a:pPr indent="0" marL="0">
+              <a:buNone/>
+            </a:pPr>
+            <a:r>
+              <a:rPr lang="en-US" sz="1600" dirty="0">
+                <a:solidFill>
+                  <a:srgbClr val="64748B"/>
+                </a:solidFill>
+                <a:latin typeface="Segoe UI" pitchFamily="34" charset="0"/>
+                <a:ea typeface="Segoe UI" pitchFamily="34" charset="-122"/>
+                <a:cs typeface="Segoe UI" pitchFamily="34" charset="-120"/>
+              </a:rPr>
+              <a:t>Integradas con la API de Groq (en la nube) o con Ollama en local.</a:t>
+            </a:r>
+            <a:endParaRPr lang="en-US" sz="1600" dirty="0"/>
+          </a:p>
+        </p:txBody>
+      </p:sp>
+      <p:sp>
+        <p:nvSpPr>
+          <p:cNvPr id="5" name="Shape 3"/>
+          <p:cNvSpPr/>
+          <p:nvPr/>
+        </p:nvSpPr>
+        <p:spPr>
+          <a:xfrm>
+            <a:off x="699516" y="2286000"/>
+            <a:ext cx="3383280" cy="2651760"/>
+          </a:xfrm>
+          <a:prstGeom prst="roundRect">
+            <a:avLst>
+              <a:gd name="adj" fmla="val 4828"/>
+            </a:avLst>
+          </a:prstGeom>
+          <a:solidFill>
+            <a:srgbClr val="EEF2FF"/>
+          </a:solidFill>
+          <a:ln w="12700">
+            <a:solidFill>
+              <a:srgbClr val="C7D2FE"/>
+            </a:solidFill>
+            <a:prstDash val="solid"/>
+          </a:ln>
+        </p:spPr>
+      </p:sp>
+      <p:sp>
+        <p:nvSpPr>
+          <p:cNvPr id="6" name="Text 4"/>
+          <p:cNvSpPr/>
+          <p:nvPr/>
+        </p:nvSpPr>
+        <p:spPr>
+          <a:xfrm>
+            <a:off x="699516" y="2606040"/>
+            <a:ext cx="3383280" cy="731520"/>
+          </a:xfrm>
+          <a:prstGeom prst="rect">
+            <a:avLst/>
+          </a:prstGeom>
+          <a:noFill/>
+          <a:ln/>
+        </p:spPr>
+        <p:txBody>
+          <a:bodyPr wrap="square" rtlCol="0" anchor="ctr"/>
+          <a:lstStyle/>
+          <a:p>
+            <a:pPr algn="ctr" indent="0" marL="0">
+              <a:buNone/>
+            </a:pPr>
+            <a:r>
+              <a:rPr lang="en-US" sz="3400" dirty="0">
+                <a:solidFill>
+                  <a:srgbClr val="000000"/>
+                </a:solidFill>
+                <a:latin typeface="Segoe UI Emoji" pitchFamily="34" charset="0"/>
+                <a:ea typeface="Segoe UI Emoji" pitchFamily="34" charset="-122"/>
+                <a:cs typeface="Segoe UI Emoji" pitchFamily="34" charset="-120"/>
+              </a:rPr>
+              <a:t>✨</a:t>
+            </a:r>
+            <a:endParaRPr lang="en-US" sz="3400" dirty="0"/>
+          </a:p>
+        </p:txBody>
+      </p:sp>
+      <p:sp>
+        <p:nvSpPr>
+          <p:cNvPr id="7" name="Text 5"/>
+          <p:cNvSpPr/>
+          <p:nvPr/>
+        </p:nvSpPr>
+        <p:spPr>
+          <a:xfrm>
+            <a:off x="882396" y="3520440"/>
+            <a:ext cx="3017520" cy="548640"/>
+          </a:xfrm>
+          <a:prstGeom prst="rect">
+            <a:avLst/>
+          </a:prstGeom>
+          <a:noFill/>
+          <a:ln/>
+        </p:spPr>
+        <p:txBody>
+          <a:bodyPr wrap="square" rtlCol="0" anchor="ctr"/>
+          <a:lstStyle/>
+          <a:p>
+            <a:pPr algn="ctr" indent="0" marL="0">
+              <a:buNone/>
+            </a:pPr>
+            <a:r>
+              <a:rPr lang="en-US" sz="1700" b="1" dirty="0">
+                <a:solidFill>
+                  <a:srgbClr val="4F46E5"/>
+                </a:solidFill>
+                <a:latin typeface="Segoe UI" pitchFamily="34" charset="0"/>
+                <a:ea typeface="Segoe UI" pitchFamily="34" charset="-122"/>
+                <a:cs typeface="Segoe UI" pitchFamily="34" charset="-120"/>
+              </a:rPr>
+              <a:t>Reescritura inclusiva</a:t>
+            </a:r>
+            <a:endParaRPr lang="en-US" sz="1700" dirty="0"/>
+          </a:p>
+        </p:txBody>
+      </p:sp>
+      <p:sp>
+        <p:nvSpPr>
+          <p:cNvPr id="8" name="Text 6"/>
+          <p:cNvSpPr/>
+          <p:nvPr/>
+        </p:nvSpPr>
+        <p:spPr>
+          <a:xfrm>
+            <a:off x="973836" y="4069080"/>
+            <a:ext cx="2834640" cy="822960"/>
           </a:xfrm>
           <a:prstGeom prst="rect">
             <a:avLst/>
@@ -4929,18 +7332,11 @@
           <a:bodyPr wrap="square" rtlCol="0" anchor="t"/>
           <a:lstStyle/>
           <a:p>
-            <a:pPr marL="228600" indent="-228600">
-              <a:lnSpc>
-                <a:spcPct val="115000"/>
-              </a:lnSpc>
-              <a:spcAft>
-                <a:spcPts val="1000"/>
-              </a:spcAft>
-              <a:buSzPct val="100000"/>
-              <a:buChar char="•"/>
-            </a:pPr>
-            <a:r>
-              <a:rPr lang="en-US" sz="1900" dirty="0">
+            <a:pPr algn="ctr" indent="0" marL="0">
+              <a:buNone/>
+            </a:pPr>
+            <a:r>
+              <a:rPr lang="en-US" sz="1300" dirty="0">
                 <a:solidFill>
                   <a:srgbClr val="334155"/>
                 </a:solidFill>
@@ -4948,23 +7344,143 @@
                 <a:ea typeface="Segoe UI" pitchFamily="34" charset="-122"/>
                 <a:cs typeface="Segoe UI" pitchFamily="34" charset="-120"/>
               </a:rPr>
-              <a:t>Motor local determinista, con IA opcional para una reescritura más natural.</a:t>
-            </a:r>
-            <a:endParaRPr lang="en-US" sz="1900" dirty="0"/>
-          </a:p>
-          <a:p>
-            <a:pPr marL="228600" indent="-228600">
-              <a:lnSpc>
-                <a:spcPct val="115000"/>
-              </a:lnSpc>
-              <a:spcAft>
-                <a:spcPts val="1000"/>
-              </a:spcAft>
-              <a:buSzPct val="100000"/>
-              <a:buChar char="•"/>
-            </a:pPr>
-            <a:r>
-              <a:rPr lang="en-US" sz="1900" dirty="0">
+              <a:t>Convierte una oferta sesgada en una versión neutra y natural.</a:t>
+            </a:r>
+            <a:endParaRPr lang="en-US" sz="1300" dirty="0"/>
+          </a:p>
+        </p:txBody>
+      </p:sp>
+      <p:sp>
+        <p:nvSpPr>
+          <p:cNvPr id="9" name="Shape 7"/>
+          <p:cNvSpPr/>
+          <p:nvPr/>
+        </p:nvSpPr>
+        <p:spPr>
+          <a:xfrm>
+            <a:off x="4402836" y="2286000"/>
+            <a:ext cx="3383280" cy="2651760"/>
+          </a:xfrm>
+          <a:prstGeom prst="roundRect">
+            <a:avLst>
+              <a:gd name="adj" fmla="val 4828"/>
+            </a:avLst>
+          </a:prstGeom>
+          <a:solidFill>
+            <a:srgbClr val="EEF2FF"/>
+          </a:solidFill>
+          <a:ln w="12700">
+            <a:solidFill>
+              <a:srgbClr val="C7D2FE"/>
+            </a:solidFill>
+            <a:prstDash val="solid"/>
+          </a:ln>
+        </p:spPr>
+      </p:sp>
+      <p:sp>
+        <p:nvSpPr>
+          <p:cNvPr id="10" name="Text 8"/>
+          <p:cNvSpPr/>
+          <p:nvPr/>
+        </p:nvSpPr>
+        <p:spPr>
+          <a:xfrm>
+            <a:off x="4402836" y="2606040"/>
+            <a:ext cx="3383280" cy="731520"/>
+          </a:xfrm>
+          <a:prstGeom prst="rect">
+            <a:avLst/>
+          </a:prstGeom>
+          <a:noFill/>
+          <a:ln/>
+        </p:spPr>
+        <p:txBody>
+          <a:bodyPr wrap="square" rtlCol="0" anchor="ctr"/>
+          <a:lstStyle/>
+          <a:p>
+            <a:pPr algn="ctr" indent="0" marL="0">
+              <a:buNone/>
+            </a:pPr>
+            <a:r>
+              <a:rPr lang="en-US" sz="3400" dirty="0">
+                <a:solidFill>
+                  <a:srgbClr val="000000"/>
+                </a:solidFill>
+                <a:latin typeface="Segoe UI Emoji" pitchFamily="34" charset="0"/>
+                <a:ea typeface="Segoe UI Emoji" pitchFamily="34" charset="-122"/>
+                <a:cs typeface="Segoe UI Emoji" pitchFamily="34" charset="-120"/>
+              </a:rPr>
+              <a:t>📝</a:t>
+            </a:r>
+            <a:endParaRPr lang="en-US" sz="3400" dirty="0"/>
+          </a:p>
+        </p:txBody>
+      </p:sp>
+      <p:sp>
+        <p:nvSpPr>
+          <p:cNvPr id="11" name="Text 9"/>
+          <p:cNvSpPr/>
+          <p:nvPr/>
+        </p:nvSpPr>
+        <p:spPr>
+          <a:xfrm>
+            <a:off x="4585716" y="3520440"/>
+            <a:ext cx="3017520" cy="548640"/>
+          </a:xfrm>
+          <a:prstGeom prst="rect">
+            <a:avLst/>
+          </a:prstGeom>
+          <a:noFill/>
+          <a:ln/>
+        </p:spPr>
+        <p:txBody>
+          <a:bodyPr wrap="square" rtlCol="0" anchor="ctr"/>
+          <a:lstStyle/>
+          <a:p>
+            <a:pPr algn="ctr" indent="0" marL="0">
+              <a:buNone/>
+            </a:pPr>
+            <a:r>
+              <a:rPr lang="en-US" sz="1700" b="1" dirty="0">
+                <a:solidFill>
+                  <a:srgbClr val="4F46E5"/>
+                </a:solidFill>
+                <a:latin typeface="Segoe UI" pitchFamily="34" charset="0"/>
+                <a:ea typeface="Segoe UI" pitchFamily="34" charset="-122"/>
+                <a:cs typeface="Segoe UI" pitchFamily="34" charset="-120"/>
+              </a:rPr>
+              <a:t>Redacción de ofertas</a:t>
+            </a:r>
+            <a:endParaRPr lang="en-US" sz="1700" dirty="0"/>
+          </a:p>
+        </p:txBody>
+      </p:sp>
+      <p:sp>
+        <p:nvSpPr>
+          <p:cNvPr id="12" name="Text 10"/>
+          <p:cNvSpPr/>
+          <p:nvPr/>
+        </p:nvSpPr>
+        <p:spPr>
+          <a:xfrm>
+            <a:off x="4677156" y="4069080"/>
+            <a:ext cx="2834640" cy="822960"/>
+          </a:xfrm>
+          <a:prstGeom prst="rect">
+            <a:avLst/>
+          </a:prstGeom>
+          <a:noFill/>
+          <a:ln/>
+        </p:spPr>
+        <p:txBody>
+          <a:bodyPr wrap="square" rtlCol="0" anchor="t"/>
+          <a:lstStyle/>
+          <a:p>
+            <a:pPr algn="ctr" indent="0" marL="0">
+              <a:buNone/>
+            </a:pPr>
+            <a:r>
+              <a:rPr lang="en-US" sz="1300" dirty="0">
                 <a:solidFill>
                   <a:srgbClr val="334155"/>
                 </a:solidFill>
@@ -4972,23 +7488,143 @@
                 <a:ea typeface="Segoe UI" pitchFamily="34" charset="-122"/>
                 <a:cs typeface="Segoe UI" pitchFamily="34" charset="-120"/>
               </a:rPr>
-              <a:t>Ollama local (privado, en tu equipo).</a:t>
-            </a:r>
-            <a:endParaRPr lang="en-US" sz="1900" dirty="0"/>
-          </a:p>
-          <a:p>
-            <a:pPr marL="228600" indent="-228600">
-              <a:lnSpc>
-                <a:spcPct val="115000"/>
-              </a:lnSpc>
-              <a:spcAft>
-                <a:spcPts val="1000"/>
-              </a:spcAft>
-              <a:buSzPct val="100000"/>
-              <a:buChar char="•"/>
-            </a:pPr>
-            <a:r>
-              <a:rPr lang="en-US" sz="1900" dirty="0">
+              <a:t>Escribe una oferta completa y atractiva a partir de unos datos.</a:t>
+            </a:r>
+            <a:endParaRPr lang="en-US" sz="1300" dirty="0"/>
+          </a:p>
+        </p:txBody>
+      </p:sp>
+      <p:sp>
+        <p:nvSpPr>
+          <p:cNvPr id="13" name="Shape 11"/>
+          <p:cNvSpPr/>
+          <p:nvPr/>
+        </p:nvSpPr>
+        <p:spPr>
+          <a:xfrm>
+            <a:off x="8106156" y="2286000"/>
+            <a:ext cx="3383280" cy="2651760"/>
+          </a:xfrm>
+          <a:prstGeom prst="roundRect">
+            <a:avLst>
+              <a:gd name="adj" fmla="val 4828"/>
+            </a:avLst>
+          </a:prstGeom>
+          <a:solidFill>
+            <a:srgbClr val="EEF2FF"/>
+          </a:solidFill>
+          <a:ln w="12700">
+            <a:solidFill>
+              <a:srgbClr val="C7D2FE"/>
+            </a:solidFill>
+            <a:prstDash val="solid"/>
+          </a:ln>
+        </p:spPr>
+      </p:sp>
+      <p:sp>
+        <p:nvSpPr>
+          <p:cNvPr id="14" name="Text 12"/>
+          <p:cNvSpPr/>
+          <p:nvPr/>
+        </p:nvSpPr>
+        <p:spPr>
+          <a:xfrm>
+            <a:off x="8106156" y="2606040"/>
+            <a:ext cx="3383280" cy="731520"/>
+          </a:xfrm>
+          <a:prstGeom prst="rect">
+            <a:avLst/>
+          </a:prstGeom>
+          <a:noFill/>
+          <a:ln/>
+        </p:spPr>
+        <p:txBody>
+          <a:bodyPr wrap="square" rtlCol="0" anchor="ctr"/>
+          <a:lstStyle/>
+          <a:p>
+            <a:pPr algn="ctr" indent="0" marL="0">
+              <a:buNone/>
+            </a:pPr>
+            <a:r>
+              <a:rPr lang="en-US" sz="3400" dirty="0">
+                <a:solidFill>
+                  <a:srgbClr val="000000"/>
+                </a:solidFill>
+                <a:latin typeface="Segoe UI Emoji" pitchFamily="34" charset="0"/>
+                <a:ea typeface="Segoe UI Emoji" pitchFamily="34" charset="-122"/>
+                <a:cs typeface="Segoe UI Emoji" pitchFamily="34" charset="-120"/>
+              </a:rPr>
+              <a:t>🧑‍💼</a:t>
+            </a:r>
+            <a:endParaRPr lang="en-US" sz="3400" dirty="0"/>
+          </a:p>
+        </p:txBody>
+      </p:sp>
+      <p:sp>
+        <p:nvSpPr>
+          <p:cNvPr id="15" name="Text 13"/>
+          <p:cNvSpPr/>
+          <p:nvPr/>
+        </p:nvSpPr>
+        <p:spPr>
+          <a:xfrm>
+            <a:off x="8289036" y="3520440"/>
+            <a:ext cx="3017520" cy="548640"/>
+          </a:xfrm>
+          <a:prstGeom prst="rect">
+            <a:avLst/>
+          </a:prstGeom>
+          <a:noFill/>
+          <a:ln/>
+        </p:spPr>
+        <p:txBody>
+          <a:bodyPr wrap="square" rtlCol="0" anchor="ctr"/>
+          <a:lstStyle/>
+          <a:p>
+            <a:pPr algn="ctr" indent="0" marL="0">
+              <a:buNone/>
+            </a:pPr>
+            <a:r>
+              <a:rPr lang="en-US" sz="1700" b="1" dirty="0">
+                <a:solidFill>
+                  <a:srgbClr val="4F46E5"/>
+                </a:solidFill>
+                <a:latin typeface="Segoe UI" pitchFamily="34" charset="0"/>
+                <a:ea typeface="Segoe UI" pitchFamily="34" charset="-122"/>
+                <a:cs typeface="Segoe UI" pitchFamily="34" charset="-120"/>
+              </a:rPr>
+              <a:t>Análisis de candidato</a:t>
+            </a:r>
+            <a:endParaRPr lang="en-US" sz="1700" dirty="0"/>
+          </a:p>
+        </p:txBody>
+      </p:sp>
+      <p:sp>
+        <p:nvSpPr>
+          <p:cNvPr id="16" name="Text 14"/>
+          <p:cNvSpPr/>
+          <p:nvPr/>
+        </p:nvSpPr>
+        <p:spPr>
+          <a:xfrm>
+            <a:off x="8380476" y="4069080"/>
+            <a:ext cx="2834640" cy="822960"/>
+          </a:xfrm>
+          <a:prstGeom prst="rect">
+            <a:avLst/>
+          </a:prstGeom>
+          <a:noFill/>
+          <a:ln/>
+        </p:spPr>
+        <p:txBody>
+          <a:bodyPr wrap="square" rtlCol="0" anchor="t"/>
+          <a:lstStyle/>
+          <a:p>
+            <a:pPr algn="ctr" indent="0" marL="0">
+              <a:buNone/>
+            </a:pPr>
+            <a:r>
+              <a:rPr lang="en-US" sz="1300" dirty="0">
                 <a:solidFill>
                   <a:srgbClr val="334155"/>
                 </a:solidFill>
@@ -4996,46 +7632,45 @@
                 <a:ea typeface="Segoe UI" pitchFamily="34" charset="-122"/>
                 <a:cs typeface="Segoe UI" pitchFamily="34" charset="-120"/>
               </a:rPr>
-              <a:t>Proveedor hospedado compatible con OpenAI (Groq): IA para todos en la web.</a:t>
-            </a:r>
-            <a:endParaRPr lang="en-US" sz="1900" dirty="0"/>
-          </a:p>
-          <a:p>
-            <a:pPr marL="228600" indent="-228600">
-              <a:lnSpc>
-                <a:spcPct val="115000"/>
-              </a:lnSpc>
-              <a:spcAft>
-                <a:spcPts val="1000"/>
-              </a:spcAft>
-              <a:buSzPct val="100000"/>
-              <a:buChar char="•"/>
-            </a:pPr>
-            <a:r>
-              <a:rPr lang="en-US" sz="1900" dirty="0">
-                <a:solidFill>
-                  <a:srgbClr val="334155"/>
-                </a:solidFill>
-                <a:latin typeface="Segoe UI" pitchFamily="34" charset="0"/>
-                <a:ea typeface="Segoe UI" pitchFamily="34" charset="-122"/>
-                <a:cs typeface="Segoe UI" pitchFamily="34" charset="-120"/>
-              </a:rPr>
-              <a:t>Degradación elegante: sin IA, se usa la reescritura determinista.</a:t>
-            </a:r>
-            <a:endParaRPr lang="en-US" sz="1900" dirty="0"/>
-          </a:p>
-        </p:txBody>
-      </p:sp>
-      <p:sp>
-        <p:nvSpPr>
-          <p:cNvPr id="5" name="Text 3"/>
+              <a:t>Resume fortalezas, carencias y una recomendación (CV ↔ oferta).</a:t>
+            </a:r>
+            <a:endParaRPr lang="en-US" sz="1300" dirty="0"/>
+          </a:p>
+        </p:txBody>
+      </p:sp>
+      <p:sp>
+        <p:nvSpPr>
+          <p:cNvPr id="17" name="Shape 15"/>
+          <p:cNvSpPr/>
+          <p:nvPr/>
+        </p:nvSpPr>
+        <p:spPr>
+          <a:xfrm>
+            <a:off x="640080" y="6309360"/>
+            <a:ext cx="10908792" cy="0"/>
+          </a:xfrm>
+          <a:prstGeom prst="line">
+            <a:avLst/>
+          </a:prstGeom>
+          <a:noFill/>
+          <a:ln w="12700">
+            <a:solidFill>
+              <a:srgbClr val="E2E8F0"/>
+            </a:solidFill>
+            <a:prstDash val="solid"/>
+          </a:ln>
+        </p:spPr>
+      </p:sp>
+      <p:sp>
+        <p:nvSpPr>
+          <p:cNvPr id="18" name="Text 16"/>
           <p:cNvSpPr/>
           <p:nvPr/>
         </p:nvSpPr>
         <p:spPr>
           <a:xfrm>
             <a:off x="640080" y="6400800"/>
-            <a:ext cx="7315200" cy="274320"/>
+            <a:ext cx="8229600" cy="274320"/>
           </a:xfrm>
           <a:prstGeom prst="rect">
             <a:avLst/>
@@ -5067,7 +7702,7 @@
       </p:sp>
       <p:sp>
         <p:nvSpPr>
-          <p:cNvPr id="6" name="Text 4"/>
+          <p:cNvPr id="19" name="Text 17"/>
           <p:cNvSpPr/>
           <p:nvPr/>
         </p:nvSpPr>
@@ -5189,7 +7824,7 @@
                 <a:ea typeface="Segoe UI" pitchFamily="34" charset="-122"/>
                 <a:cs typeface="Segoe UI" pitchFamily="34" charset="-120"/>
               </a:rPr>
-              <a:t>Del lado del candidato y sourcing</a:t>
+              <a:t>Arquitectura de IA · Groq + Ollama</a:t>
             </a:r>
             <a:endParaRPr lang="en-US" sz="3000" dirty="0"/>
           </a:p>
@@ -5197,37 +7832,563 @@
       </p:sp>
       <p:sp>
         <p:nvSpPr>
-          <p:cNvPr id="4" name="Text 2"/>
-          <p:cNvSpPr/>
-          <p:nvPr/>
-        </p:nvSpPr>
-        <p:spPr>
-          <a:xfrm>
-            <a:off x="822960" y="1737360"/>
-            <a:ext cx="10515600" cy="4206240"/>
-          </a:xfrm>
-          <a:prstGeom prst="rect">
-            <a:avLst/>
-          </a:prstGeom>
-          <a:noFill/>
-          <a:ln/>
-        </p:spPr>
-        <p:txBody>
-          <a:bodyPr wrap="square" rtlCol="0" anchor="t"/>
-          <a:lstStyle/>
-          <a:p>
-            <a:pPr marL="228600" indent="-228600">
-              <a:lnSpc>
-                <a:spcPct val="115000"/>
-              </a:lnSpc>
-              <a:spcAft>
-                <a:spcPts val="1000"/>
-              </a:spcAft>
-              <a:buSzPct val="100000"/>
-              <a:buChar char="•"/>
-            </a:pPr>
-            <a:r>
-              <a:rPr lang="en-US" sz="1900" dirty="0">
+          <p:cNvPr id="4" name="Shape 2"/>
+          <p:cNvSpPr/>
+          <p:nvPr/>
+        </p:nvSpPr>
+        <p:spPr>
+          <a:xfrm>
+            <a:off x="731520" y="2468880"/>
+            <a:ext cx="2286000" cy="1097280"/>
+          </a:xfrm>
+          <a:prstGeom prst="roundRect">
+            <a:avLst>
+              <a:gd name="adj" fmla="val 8333"/>
+            </a:avLst>
+          </a:prstGeom>
+          <a:solidFill>
+            <a:srgbClr val="F1F5F9"/>
+          </a:solidFill>
+          <a:ln w="19050">
+            <a:solidFill>
+              <a:srgbClr val="64748B"/>
+            </a:solidFill>
+            <a:prstDash val="solid"/>
+          </a:ln>
+        </p:spPr>
+      </p:sp>
+      <p:sp>
+        <p:nvSpPr>
+          <p:cNvPr id="5" name="Text 3"/>
+          <p:cNvSpPr/>
+          <p:nvPr/>
+        </p:nvSpPr>
+        <p:spPr>
+          <a:xfrm>
+            <a:off x="822960" y="2606040"/>
+            <a:ext cx="2103120" cy="365760"/>
+          </a:xfrm>
+          <a:prstGeom prst="rect">
+            <a:avLst/>
+          </a:prstGeom>
+          <a:noFill/>
+          <a:ln/>
+        </p:spPr>
+        <p:txBody>
+          <a:bodyPr wrap="square" rtlCol="0" anchor="ctr"/>
+          <a:lstStyle/>
+          <a:p>
+            <a:pPr algn="ctr" indent="0" marL="0">
+              <a:buNone/>
+            </a:pPr>
+            <a:r>
+              <a:rPr lang="en-US" sz="1400" b="1" dirty="0">
+                <a:solidFill>
+                  <a:srgbClr val="0F172A"/>
+                </a:solidFill>
+                <a:latin typeface="Segoe UI" pitchFamily="34" charset="0"/>
+                <a:ea typeface="Segoe UI" pitchFamily="34" charset="-122"/>
+                <a:cs typeface="Segoe UI" pitchFamily="34" charset="-120"/>
+              </a:rPr>
+              <a:t>Usuario</a:t>
+            </a:r>
+            <a:endParaRPr lang="en-US" sz="1400" dirty="0"/>
+          </a:p>
+        </p:txBody>
+      </p:sp>
+      <p:sp>
+        <p:nvSpPr>
+          <p:cNvPr id="6" name="Text 4"/>
+          <p:cNvSpPr/>
+          <p:nvPr/>
+        </p:nvSpPr>
+        <p:spPr>
+          <a:xfrm>
+            <a:off x="822960" y="3017520"/>
+            <a:ext cx="2103120" cy="457200"/>
+          </a:xfrm>
+          <a:prstGeom prst="rect">
+            <a:avLst/>
+          </a:prstGeom>
+          <a:noFill/>
+          <a:ln/>
+        </p:spPr>
+        <p:txBody>
+          <a:bodyPr wrap="square" rtlCol="0" anchor="ctr"/>
+          <a:lstStyle/>
+          <a:p>
+            <a:pPr algn="ctr" indent="0" marL="0">
+              <a:buNone/>
+            </a:pPr>
+            <a:r>
+              <a:rPr lang="en-US" sz="1100" dirty="0">
+                <a:solidFill>
+                  <a:srgbClr val="64748B"/>
+                </a:solidFill>
+                <a:latin typeface="Segoe UI" pitchFamily="34" charset="0"/>
+                <a:ea typeface="Segoe UI" pitchFamily="34" charset="-122"/>
+                <a:cs typeface="Segoe UI" pitchFamily="34" charset="-120"/>
+              </a:rPr>
+              <a:t>Navegador</a:t>
+            </a:r>
+            <a:endParaRPr lang="en-US" sz="1100" dirty="0"/>
+          </a:p>
+        </p:txBody>
+      </p:sp>
+      <p:sp>
+        <p:nvSpPr>
+          <p:cNvPr id="7" name="Shape 5"/>
+          <p:cNvSpPr/>
+          <p:nvPr/>
+        </p:nvSpPr>
+        <p:spPr>
+          <a:xfrm>
+            <a:off x="3840480" y="2468880"/>
+            <a:ext cx="2926080" cy="1097280"/>
+          </a:xfrm>
+          <a:prstGeom prst="roundRect">
+            <a:avLst>
+              <a:gd name="adj" fmla="val 8333"/>
+            </a:avLst>
+          </a:prstGeom>
+          <a:solidFill>
+            <a:srgbClr val="EEF2FF"/>
+          </a:solidFill>
+          <a:ln w="19050">
+            <a:solidFill>
+              <a:srgbClr val="4F46E5"/>
+            </a:solidFill>
+            <a:prstDash val="solid"/>
+          </a:ln>
+        </p:spPr>
+      </p:sp>
+      <p:sp>
+        <p:nvSpPr>
+          <p:cNvPr id="8" name="Text 6"/>
+          <p:cNvSpPr/>
+          <p:nvPr/>
+        </p:nvSpPr>
+        <p:spPr>
+          <a:xfrm>
+            <a:off x="3931920" y="2606040"/>
+            <a:ext cx="2743200" cy="365760"/>
+          </a:xfrm>
+          <a:prstGeom prst="rect">
+            <a:avLst/>
+          </a:prstGeom>
+          <a:noFill/>
+          <a:ln/>
+        </p:spPr>
+        <p:txBody>
+          <a:bodyPr wrap="square" rtlCol="0" anchor="ctr"/>
+          <a:lstStyle/>
+          <a:p>
+            <a:pPr algn="ctr" indent="0" marL="0">
+              <a:buNone/>
+            </a:pPr>
+            <a:r>
+              <a:rPr lang="en-US" sz="1400" b="1" dirty="0">
+                <a:solidFill>
+                  <a:srgbClr val="0F172A"/>
+                </a:solidFill>
+                <a:latin typeface="Segoe UI" pitchFamily="34" charset="0"/>
+                <a:ea typeface="Segoe UI" pitchFamily="34" charset="-122"/>
+                <a:cs typeface="Segoe UI" pitchFamily="34" charset="-120"/>
+              </a:rPr>
+              <a:t>RecruitKit</a:t>
+            </a:r>
+            <a:endParaRPr lang="en-US" sz="1400" dirty="0"/>
+          </a:p>
+        </p:txBody>
+      </p:sp>
+      <p:sp>
+        <p:nvSpPr>
+          <p:cNvPr id="9" name="Text 7"/>
+          <p:cNvSpPr/>
+          <p:nvPr/>
+        </p:nvSpPr>
+        <p:spPr>
+          <a:xfrm>
+            <a:off x="3931920" y="3017520"/>
+            <a:ext cx="2743200" cy="457200"/>
+          </a:xfrm>
+          <a:prstGeom prst="rect">
+            <a:avLst/>
+          </a:prstGeom>
+          <a:noFill/>
+          <a:ln/>
+        </p:spPr>
+        <p:txBody>
+          <a:bodyPr wrap="square" rtlCol="0" anchor="ctr"/>
+          <a:lstStyle/>
+          <a:p>
+            <a:pPr algn="ctr" indent="0" marL="0">
+              <a:buNone/>
+            </a:pPr>
+            <a:r>
+              <a:rPr lang="en-US" sz="1100" dirty="0">
+                <a:solidFill>
+                  <a:srgbClr val="64748B"/>
+                </a:solidFill>
+                <a:latin typeface="Segoe UI" pitchFamily="34" charset="0"/>
+                <a:ea typeface="Segoe UI" pitchFamily="34" charset="-122"/>
+                <a:cs typeface="Segoe UI" pitchFamily="34" charset="-120"/>
+              </a:rPr>
+              <a:t>Next.js en Vercel · /api/ai</a:t>
+            </a:r>
+            <a:endParaRPr lang="en-US" sz="1100" dirty="0"/>
+          </a:p>
+        </p:txBody>
+      </p:sp>
+      <p:sp>
+        <p:nvSpPr>
+          <p:cNvPr id="10" name="Shape 8"/>
+          <p:cNvSpPr/>
+          <p:nvPr/>
+        </p:nvSpPr>
+        <p:spPr>
+          <a:xfrm>
+            <a:off x="7772400" y="1508760"/>
+            <a:ext cx="3657600" cy="1097280"/>
+          </a:xfrm>
+          <a:prstGeom prst="roundRect">
+            <a:avLst>
+              <a:gd name="adj" fmla="val 8333"/>
+            </a:avLst>
+          </a:prstGeom>
+          <a:solidFill>
+            <a:srgbClr val="F0FDF4"/>
+          </a:solidFill>
+          <a:ln w="19050">
+            <a:solidFill>
+              <a:srgbClr val="16A34A"/>
+            </a:solidFill>
+            <a:prstDash val="solid"/>
+          </a:ln>
+        </p:spPr>
+      </p:sp>
+      <p:sp>
+        <p:nvSpPr>
+          <p:cNvPr id="11" name="Text 9"/>
+          <p:cNvSpPr/>
+          <p:nvPr/>
+        </p:nvSpPr>
+        <p:spPr>
+          <a:xfrm>
+            <a:off x="7863840" y="1645920"/>
+            <a:ext cx="3474720" cy="365760"/>
+          </a:xfrm>
+          <a:prstGeom prst="rect">
+            <a:avLst/>
+          </a:prstGeom>
+          <a:noFill/>
+          <a:ln/>
+        </p:spPr>
+        <p:txBody>
+          <a:bodyPr wrap="square" rtlCol="0" anchor="ctr"/>
+          <a:lstStyle/>
+          <a:p>
+            <a:pPr algn="ctr" indent="0" marL="0">
+              <a:buNone/>
+            </a:pPr>
+            <a:r>
+              <a:rPr lang="en-US" sz="1400" b="1" dirty="0">
+                <a:solidFill>
+                  <a:srgbClr val="0F172A"/>
+                </a:solidFill>
+                <a:latin typeface="Segoe UI" pitchFamily="34" charset="0"/>
+                <a:ea typeface="Segoe UI" pitchFamily="34" charset="-122"/>
+                <a:cs typeface="Segoe UI" pitchFamily="34" charset="-120"/>
+              </a:rPr>
+              <a:t>Groq API (nube)</a:t>
+            </a:r>
+            <a:endParaRPr lang="en-US" sz="1400" dirty="0"/>
+          </a:p>
+        </p:txBody>
+      </p:sp>
+      <p:sp>
+        <p:nvSpPr>
+          <p:cNvPr id="12" name="Text 10"/>
+          <p:cNvSpPr/>
+          <p:nvPr/>
+        </p:nvSpPr>
+        <p:spPr>
+          <a:xfrm>
+            <a:off x="7863840" y="2057400"/>
+            <a:ext cx="3474720" cy="457200"/>
+          </a:xfrm>
+          <a:prstGeom prst="rect">
+            <a:avLst/>
+          </a:prstGeom>
+          <a:noFill/>
+          <a:ln/>
+        </p:spPr>
+        <p:txBody>
+          <a:bodyPr wrap="square" rtlCol="0" anchor="ctr"/>
+          <a:lstStyle/>
+          <a:p>
+            <a:pPr algn="ctr" indent="0" marL="0">
+              <a:buNone/>
+            </a:pPr>
+            <a:r>
+              <a:rPr lang="en-US" sz="1100" dirty="0">
+                <a:solidFill>
+                  <a:srgbClr val="64748B"/>
+                </a:solidFill>
+                <a:latin typeface="Segoe UI" pitchFamily="34" charset="0"/>
+                <a:ea typeface="Segoe UI" pitchFamily="34" charset="-122"/>
+                <a:cs typeface="Segoe UI" pitchFamily="34" charset="-120"/>
+              </a:rPr>
+              <a:t>IA para todos en la web</a:t>
+            </a:r>
+            <a:endParaRPr lang="en-US" sz="1100" dirty="0"/>
+          </a:p>
+        </p:txBody>
+      </p:sp>
+      <p:sp>
+        <p:nvSpPr>
+          <p:cNvPr id="13" name="Shape 11"/>
+          <p:cNvSpPr/>
+          <p:nvPr/>
+        </p:nvSpPr>
+        <p:spPr>
+          <a:xfrm>
+            <a:off x="7772400" y="3429000"/>
+            <a:ext cx="3657600" cy="1097280"/>
+          </a:xfrm>
+          <a:prstGeom prst="roundRect">
+            <a:avLst>
+              <a:gd name="adj" fmla="val 8333"/>
+            </a:avLst>
+          </a:prstGeom>
+          <a:solidFill>
+            <a:srgbClr val="F5F3FF"/>
+          </a:solidFill>
+          <a:ln w="19050">
+            <a:solidFill>
+              <a:srgbClr val="8B5CF6"/>
+            </a:solidFill>
+            <a:prstDash val="solid"/>
+          </a:ln>
+        </p:spPr>
+      </p:sp>
+      <p:sp>
+        <p:nvSpPr>
+          <p:cNvPr id="14" name="Text 12"/>
+          <p:cNvSpPr/>
+          <p:nvPr/>
+        </p:nvSpPr>
+        <p:spPr>
+          <a:xfrm>
+            <a:off x="7863840" y="3566160"/>
+            <a:ext cx="3474720" cy="365760"/>
+          </a:xfrm>
+          <a:prstGeom prst="rect">
+            <a:avLst/>
+          </a:prstGeom>
+          <a:noFill/>
+          <a:ln/>
+        </p:spPr>
+        <p:txBody>
+          <a:bodyPr wrap="square" rtlCol="0" anchor="ctr"/>
+          <a:lstStyle/>
+          <a:p>
+            <a:pPr algn="ctr" indent="0" marL="0">
+              <a:buNone/>
+            </a:pPr>
+            <a:r>
+              <a:rPr lang="en-US" sz="1400" b="1" dirty="0">
+                <a:solidFill>
+                  <a:srgbClr val="0F172A"/>
+                </a:solidFill>
+                <a:latin typeface="Segoe UI" pitchFamily="34" charset="0"/>
+                <a:ea typeface="Segoe UI" pitchFamily="34" charset="-122"/>
+                <a:cs typeface="Segoe UI" pitchFamily="34" charset="-120"/>
+              </a:rPr>
+              <a:t>Ollama (local)</a:t>
+            </a:r>
+            <a:endParaRPr lang="en-US" sz="1400" dirty="0"/>
+          </a:p>
+        </p:txBody>
+      </p:sp>
+      <p:sp>
+        <p:nvSpPr>
+          <p:cNvPr id="15" name="Text 13"/>
+          <p:cNvSpPr/>
+          <p:nvPr/>
+        </p:nvSpPr>
+        <p:spPr>
+          <a:xfrm>
+            <a:off x="7863840" y="3977640"/>
+            <a:ext cx="3474720" cy="457200"/>
+          </a:xfrm>
+          <a:prstGeom prst="rect">
+            <a:avLst/>
+          </a:prstGeom>
+          <a:noFill/>
+          <a:ln/>
+        </p:spPr>
+        <p:txBody>
+          <a:bodyPr wrap="square" rtlCol="0" anchor="ctr"/>
+          <a:lstStyle/>
+          <a:p>
+            <a:pPr algn="ctr" indent="0" marL="0">
+              <a:buNone/>
+            </a:pPr>
+            <a:r>
+              <a:rPr lang="en-US" sz="1100" dirty="0">
+                <a:solidFill>
+                  <a:srgbClr val="64748B"/>
+                </a:solidFill>
+                <a:latin typeface="Segoe UI" pitchFamily="34" charset="0"/>
+                <a:ea typeface="Segoe UI" pitchFamily="34" charset="-122"/>
+                <a:cs typeface="Segoe UI" pitchFamily="34" charset="-120"/>
+              </a:rPr>
+              <a:t>privado, sin coste</a:t>
+            </a:r>
+            <a:endParaRPr lang="en-US" sz="1100" dirty="0"/>
+          </a:p>
+        </p:txBody>
+      </p:sp>
+      <p:sp>
+        <p:nvSpPr>
+          <p:cNvPr id="16" name="Shape 14"/>
+          <p:cNvSpPr/>
+          <p:nvPr/>
+        </p:nvSpPr>
+        <p:spPr>
+          <a:xfrm>
+            <a:off x="3017520" y="3017520"/>
+            <a:ext cx="822960" cy="9144"/>
+          </a:xfrm>
+          <a:prstGeom prst="line">
+            <a:avLst/>
+          </a:prstGeom>
+          <a:noFill/>
+          <a:ln w="25400">
+            <a:solidFill>
+              <a:srgbClr val="4F46E5"/>
+            </a:solidFill>
+            <a:prstDash val="solid"/>
+            <a:tailEnd type="triangle"/>
+          </a:ln>
+        </p:spPr>
+      </p:sp>
+      <p:sp>
+        <p:nvSpPr>
+          <p:cNvPr id="17" name="Shape 15"/>
+          <p:cNvSpPr/>
+          <p:nvPr/>
+        </p:nvSpPr>
+        <p:spPr>
+          <a:xfrm flipV="1">
+            <a:off x="6766560" y="2057400"/>
+            <a:ext cx="1005840" cy="777240"/>
+          </a:xfrm>
+          <a:prstGeom prst="line">
+            <a:avLst/>
+          </a:prstGeom>
+          <a:noFill/>
+          <a:ln w="25400">
+            <a:solidFill>
+              <a:srgbClr val="4F46E5"/>
+            </a:solidFill>
+            <a:prstDash val="solid"/>
+            <a:tailEnd type="triangle"/>
+          </a:ln>
+        </p:spPr>
+      </p:sp>
+      <p:sp>
+        <p:nvSpPr>
+          <p:cNvPr id="18" name="Shape 16"/>
+          <p:cNvSpPr/>
+          <p:nvPr/>
+        </p:nvSpPr>
+        <p:spPr>
+          <a:xfrm>
+            <a:off x="6766560" y="3200400"/>
+            <a:ext cx="1005840" cy="777240"/>
+          </a:xfrm>
+          <a:prstGeom prst="line">
+            <a:avLst/>
+          </a:prstGeom>
+          <a:noFill/>
+          <a:ln w="25400">
+            <a:solidFill>
+              <a:srgbClr val="4F46E5"/>
+            </a:solidFill>
+            <a:prstDash val="solid"/>
+            <a:tailEnd type="triangle"/>
+          </a:ln>
+        </p:spPr>
+      </p:sp>
+      <p:sp>
+        <p:nvSpPr>
+          <p:cNvPr id="19" name="Shape 17"/>
+          <p:cNvSpPr/>
+          <p:nvPr/>
+        </p:nvSpPr>
+        <p:spPr>
+          <a:xfrm>
+            <a:off x="731520" y="4937760"/>
+            <a:ext cx="10698480" cy="822960"/>
+          </a:xfrm>
+          <a:prstGeom prst="roundRect">
+            <a:avLst>
+              <a:gd name="adj" fmla="val 11111"/>
+            </a:avLst>
+          </a:prstGeom>
+          <a:solidFill>
+            <a:srgbClr val="FFF7ED"/>
+          </a:solidFill>
+          <a:ln w="12700">
+            <a:solidFill>
+              <a:srgbClr val="FED7AA"/>
+            </a:solidFill>
+            <a:prstDash val="solid"/>
+          </a:ln>
+        </p:spPr>
+      </p:sp>
+      <p:sp>
+        <p:nvSpPr>
+          <p:cNvPr id="20" name="Text 18"/>
+          <p:cNvSpPr/>
+          <p:nvPr/>
+        </p:nvSpPr>
+        <p:spPr>
+          <a:xfrm>
+            <a:off x="914400" y="5074920"/>
+            <a:ext cx="10332720" cy="548640"/>
+          </a:xfrm>
+          <a:prstGeom prst="rect">
+            <a:avLst/>
+          </a:prstGeom>
+          <a:noFill/>
+          <a:ln/>
+        </p:spPr>
+        <p:txBody>
+          <a:bodyPr wrap="square" rtlCol="0" anchor="ctr"/>
+          <a:lstStyle/>
+          <a:p>
+            <a:pPr indent="0" marL="0">
+              <a:buNone/>
+            </a:pPr>
+            <a:r>
+              <a:rPr lang="en-US" sz="1300" b="1" dirty="0">
+                <a:solidFill>
+                  <a:srgbClr val="9A3412"/>
+                </a:solidFill>
+                <a:latin typeface="Segoe UI" pitchFamily="34" charset="0"/>
+                <a:ea typeface="Segoe UI" pitchFamily="34" charset="-122"/>
+                <a:cs typeface="Segoe UI" pitchFamily="34" charset="-120"/>
+              </a:rPr>
+              <a:t>Degradación elegante: </a:t>
+            </a:r>
+            <a:pPr indent="0" marL="0">
+              <a:buNone/>
+            </a:pPr>
+            <a:r>
+              <a:rPr lang="en-US" sz="1300" dirty="0">
                 <a:solidFill>
                   <a:srgbClr val="334155"/>
                 </a:solidFill>
@@ -5235,70 +8396,45 @@
                 <a:ea typeface="Segoe UI" pitchFamily="34" charset="-122"/>
                 <a:cs typeface="Segoe UI" pitchFamily="34" charset="-120"/>
               </a:rPr>
-              <a:t>Compatibilidad ATS: encaje oferta ↔ CV y palabras clave que faltan.</a:t>
-            </a:r>
-            <a:endParaRPr lang="en-US" sz="1900" dirty="0"/>
-          </a:p>
-          <a:p>
-            <a:pPr marL="228600" indent="-228600">
-              <a:lnSpc>
-                <a:spcPct val="115000"/>
-              </a:lnSpc>
-              <a:spcAft>
-                <a:spcPts val="1000"/>
-              </a:spcAft>
-              <a:buSzPct val="100000"/>
-              <a:buChar char="•"/>
-            </a:pPr>
-            <a:r>
-              <a:rPr lang="en-US" sz="1900" dirty="0">
-                <a:solidFill>
-                  <a:srgbClr val="334155"/>
-                </a:solidFill>
-                <a:latin typeface="Segoe UI" pitchFamily="34" charset="0"/>
-                <a:ea typeface="Segoe UI" pitchFamily="34" charset="-122"/>
-                <a:cs typeface="Segoe UI" pitchFamily="34" charset="-120"/>
-              </a:rPr>
-              <a:t>Ranking de candidatos: ordena varios CV por su encaje con la oferta.</a:t>
-            </a:r>
-            <a:endParaRPr lang="en-US" sz="1900" dirty="0"/>
-          </a:p>
-          <a:p>
-            <a:pPr marL="228600" indent="-228600">
-              <a:lnSpc>
-                <a:spcPct val="115000"/>
-              </a:lnSpc>
-              <a:spcAft>
-                <a:spcPts val="1000"/>
-              </a:spcAft>
-              <a:buSzPct val="100000"/>
-              <a:buChar char="•"/>
-            </a:pPr>
-            <a:r>
-              <a:rPr lang="en-US" sz="1900" dirty="0">
-                <a:solidFill>
-                  <a:srgbClr val="334155"/>
-                </a:solidFill>
-                <a:latin typeface="Segoe UI" pitchFamily="34" charset="0"/>
-                <a:ea typeface="Segoe UI" pitchFamily="34" charset="-122"/>
-                <a:cs typeface="Segoe UI" pitchFamily="34" charset="-120"/>
-              </a:rPr>
-              <a:t>Buscador booleano: cadenas para LinkedIn y Google X-ray.</a:t>
-            </a:r>
-            <a:endParaRPr lang="en-US" sz="1900" dirty="0"/>
-          </a:p>
-        </p:txBody>
-      </p:sp>
-      <p:sp>
-        <p:nvSpPr>
-          <p:cNvPr id="5" name="Text 3"/>
+              <a:t>si no hay IA disponible, la app usa la reescritura determinista del lexicón. La clave de la API vive solo en el servidor.</a:t>
+            </a:r>
+            <a:endParaRPr lang="en-US" sz="1300" dirty="0"/>
+          </a:p>
+        </p:txBody>
+      </p:sp>
+      <p:sp>
+        <p:nvSpPr>
+          <p:cNvPr id="21" name="Shape 19"/>
+          <p:cNvSpPr/>
+          <p:nvPr/>
+        </p:nvSpPr>
+        <p:spPr>
+          <a:xfrm>
+            <a:off x="640080" y="6309360"/>
+            <a:ext cx="10908792" cy="0"/>
+          </a:xfrm>
+          <a:prstGeom prst="line">
+            <a:avLst/>
+          </a:prstGeom>
+          <a:noFill/>
+          <a:ln w="12700">
+            <a:solidFill>
+              <a:srgbClr val="E2E8F0"/>
+            </a:solidFill>
+            <a:prstDash val="solid"/>
+          </a:ln>
+        </p:spPr>
+      </p:sp>
+      <p:sp>
+        <p:nvSpPr>
+          <p:cNvPr id="22" name="Text 20"/>
           <p:cNvSpPr/>
           <p:nvPr/>
         </p:nvSpPr>
         <p:spPr>
           <a:xfrm>
             <a:off x="640080" y="6400800"/>
-            <a:ext cx="7315200" cy="274320"/>
+            <a:ext cx="8229600" cy="274320"/>
           </a:xfrm>
           <a:prstGeom prst="rect">
             <a:avLst/>
@@ -5330,7 +8466,7 @@
       </p:sp>
       <p:sp>
         <p:nvSpPr>
-          <p:cNvPr id="6" name="Text 4"/>
+          <p:cNvPr id="23" name="Text 21"/>
           <p:cNvSpPr/>
           <p:nvPr/>
         </p:nvSpPr>
@@ -5452,7 +8588,7 @@
                 <a:ea typeface="Segoe UI" pitchFamily="34" charset="-122"/>
                 <a:cs typeface="Segoe UI" pitchFamily="34" charset="-120"/>
               </a:rPr>
-              <a:t>Entrevista y comunicación</a:t>
+              <a:t>Del lado del candidato y sourcing</a:t>
             </a:r>
             <a:endParaRPr lang="en-US" sz="3000" dirty="0"/>
           </a:p>
@@ -5467,7 +8603,7 @@
         <p:spPr>
           <a:xfrm>
             <a:off x="822960" y="1737360"/>
-            <a:ext cx="10515600" cy="4206240"/>
+            <a:ext cx="10515600" cy="4023360"/>
           </a:xfrm>
           <a:prstGeom prst="rect">
             <a:avLst/>
@@ -5498,7 +8634,7 @@
                 <a:ea typeface="Segoe UI" pitchFamily="34" charset="-122"/>
                 <a:cs typeface="Segoe UI" pitchFamily="34" charset="-120"/>
               </a:rPr>
-              <a:t>Banco de preguntas por competencia para entrevistas estructuradas.</a:t>
+              <a:t>Compatibilidad ATS: encaje oferta ↔ CV, palabras clave que faltan y análisis del candidato con IA.</a:t>
             </a:r>
             <a:endParaRPr lang="en-US" sz="1900" dirty="0"/>
           </a:p>
@@ -5522,7 +8658,7 @@
                 <a:ea typeface="Segoe UI" pitchFamily="34" charset="-122"/>
                 <a:cs typeface="Segoe UI" pitchFamily="34" charset="-120"/>
               </a:rPr>
-              <a:t>Lista de preguntas a evitar (legalmente sensibles: edad, estado civil…).</a:t>
+              <a:t>Ranking de candidatos: ordena varios CV por su encaje con la oferta.</a:t>
             </a:r>
             <a:endParaRPr lang="en-US" sz="1900" dirty="0"/>
           </a:p>
@@ -5546,7 +8682,7 @@
                 <a:ea typeface="Segoe UI" pitchFamily="34" charset="-122"/>
                 <a:cs typeface="Segoe UI" pitchFamily="34" charset="-120"/>
               </a:rPr>
-              <a:t>Plantillas de email: invitación, información, oferta y rechazo.</a:t>
+              <a:t>Buscador booleano: cadenas para LinkedIn y Google X-ray.</a:t>
             </a:r>
             <a:endParaRPr lang="en-US" sz="1900" dirty="0"/>
           </a:p>
@@ -5554,14 +8690,37 @@
       </p:sp>
       <p:sp>
         <p:nvSpPr>
-          <p:cNvPr id="5" name="Text 3"/>
+          <p:cNvPr id="5" name="Shape 3"/>
+          <p:cNvSpPr/>
+          <p:nvPr/>
+        </p:nvSpPr>
+        <p:spPr>
+          <a:xfrm>
+            <a:off x="640080" y="6309360"/>
+            <a:ext cx="10908792" cy="0"/>
+          </a:xfrm>
+          <a:prstGeom prst="line">
+            <a:avLst/>
+          </a:prstGeom>
+          <a:noFill/>
+          <a:ln w="12700">
+            <a:solidFill>
+              <a:srgbClr val="E2E8F0"/>
+            </a:solidFill>
+            <a:prstDash val="solid"/>
+          </a:ln>
+        </p:spPr>
+      </p:sp>
+      <p:sp>
+        <p:nvSpPr>
+          <p:cNvPr id="6" name="Text 4"/>
           <p:cNvSpPr/>
           <p:nvPr/>
         </p:nvSpPr>
         <p:spPr>
           <a:xfrm>
             <a:off x="640080" y="6400800"/>
-            <a:ext cx="7315200" cy="274320"/>
+            <a:ext cx="8229600" cy="274320"/>
           </a:xfrm>
           <a:prstGeom prst="rect">
             <a:avLst/>
@@ -5593,7 +8752,7 @@
       </p:sp>
       <p:sp>
         <p:nvSpPr>
-          <p:cNvPr id="6" name="Text 4"/>
+          <p:cNvPr id="7" name="Text 5"/>
           <p:cNvSpPr/>
           <p:nvPr/>
         </p:nvSpPr>
@@ -5715,7 +8874,7 @@
                 <a:ea typeface="Segoe UI" pitchFamily="34" charset="-122"/>
                 <a:cs typeface="Segoe UI" pitchFamily="34" charset="-120"/>
               </a:rPr>
-              <a:t>Stack técnico</a:t>
+              <a:t>Entrevista y comunicación</a:t>
             </a:r>
             <a:endParaRPr lang="en-US" sz="3000" dirty="0"/>
           </a:p>
@@ -5730,7 +8889,7 @@
         <p:spPr>
           <a:xfrm>
             <a:off x="822960" y="1737360"/>
-            <a:ext cx="10515600" cy="4206240"/>
+            <a:ext cx="10515600" cy="4023360"/>
           </a:xfrm>
           <a:prstGeom prst="rect">
             <a:avLst/>
@@ -5761,7 +8920,7 @@
                 <a:ea typeface="Segoe UI" pitchFamily="34" charset="-122"/>
                 <a:cs typeface="Segoe UI" pitchFamily="34" charset="-120"/>
               </a:rPr>
-              <a:t>Next.js 15 · React 19 · TypeScript.</a:t>
+              <a:t>Banco de preguntas por competencia para entrevistas estructuradas.</a:t>
             </a:r>
             <a:endParaRPr lang="en-US" sz="1900" dirty="0"/>
           </a:p>
@@ -5785,7 +8944,7 @@
                 <a:ea typeface="Segoe UI" pitchFamily="34" charset="-122"/>
                 <a:cs typeface="Segoe UI" pitchFamily="34" charset="-120"/>
               </a:rPr>
-              <a:t>Tailwind CSS · Auth.js (NextAuth v5) con sesión JWT.</a:t>
+              <a:t>Lista de preguntas a evitar (legalmente sensibles: edad, estado civil…).</a:t>
             </a:r>
             <a:endParaRPr lang="en-US" sz="1900" dirty="0"/>
           </a:p>
@@ -5809,70 +8968,45 @@
                 <a:ea typeface="Segoe UI" pitchFamily="34" charset="-122"/>
                 <a:cs typeface="Segoe UI" pitchFamily="34" charset="-120"/>
               </a:rPr>
-              <a:t>Prisma + PostgreSQL (opcional).</a:t>
+              <a:t>Plantillas de email: invitación, información, oferta y rechazo.</a:t>
             </a:r>
             <a:endParaRPr lang="en-US" sz="1900" dirty="0"/>
           </a:p>
-          <a:p>
-            <a:pPr marL="228600" indent="-228600">
-              <a:lnSpc>
-                <a:spcPct val="115000"/>
-              </a:lnSpc>
-              <a:spcAft>
-                <a:spcPts val="1000"/>
-              </a:spcAft>
-              <a:buSzPct val="100000"/>
-              <a:buChar char="•"/>
-            </a:pPr>
-            <a:r>
-              <a:rPr lang="en-US" sz="1900" dirty="0">
-                <a:solidFill>
-                  <a:srgbClr val="334155"/>
-                </a:solidFill>
-                <a:latin typeface="Segoe UI" pitchFamily="34" charset="0"/>
-                <a:ea typeface="Segoe UI" pitchFamily="34" charset="-122"/>
-                <a:cs typeface="Segoe UI" pitchFamily="34" charset="-120"/>
-              </a:rPr>
-              <a:t>Vitest (tests del motor) · docx (informes Word).</a:t>
-            </a:r>
-            <a:endParaRPr lang="en-US" sz="1900" dirty="0"/>
-          </a:p>
-          <a:p>
-            <a:pPr marL="228600" indent="-228600">
-              <a:lnSpc>
-                <a:spcPct val="115000"/>
-              </a:lnSpc>
-              <a:spcAft>
-                <a:spcPts val="1000"/>
-              </a:spcAft>
-              <a:buSzPct val="100000"/>
-              <a:buChar char="•"/>
-            </a:pPr>
-            <a:r>
-              <a:rPr lang="en-US" sz="1900" dirty="0">
-                <a:solidFill>
-                  <a:srgbClr val="334155"/>
-                </a:solidFill>
-                <a:latin typeface="Segoe UI" pitchFamily="34" charset="0"/>
-                <a:ea typeface="Segoe UI" pitchFamily="34" charset="-122"/>
-                <a:cs typeface="Segoe UI" pitchFamily="34" charset="-120"/>
-              </a:rPr>
-              <a:t>Ollama / Groq (IA opcional) · Despliegue en Vercel.</a:t>
-            </a:r>
-            <a:endParaRPr lang="en-US" sz="1900" dirty="0"/>
-          </a:p>
-        </p:txBody>
-      </p:sp>
-      <p:sp>
-        <p:nvSpPr>
-          <p:cNvPr id="5" name="Text 3"/>
+        </p:txBody>
+      </p:sp>
+      <p:sp>
+        <p:nvSpPr>
+          <p:cNvPr id="5" name="Shape 3"/>
+          <p:cNvSpPr/>
+          <p:nvPr/>
+        </p:nvSpPr>
+        <p:spPr>
+          <a:xfrm>
+            <a:off x="640080" y="6309360"/>
+            <a:ext cx="10908792" cy="0"/>
+          </a:xfrm>
+          <a:prstGeom prst="line">
+            <a:avLst/>
+          </a:prstGeom>
+          <a:noFill/>
+          <a:ln w="12700">
+            <a:solidFill>
+              <a:srgbClr val="E2E8F0"/>
+            </a:solidFill>
+            <a:prstDash val="solid"/>
+          </a:ln>
+        </p:spPr>
+      </p:sp>
+      <p:sp>
+        <p:nvSpPr>
+          <p:cNvPr id="6" name="Text 4"/>
           <p:cNvSpPr/>
           <p:nvPr/>
         </p:nvSpPr>
         <p:spPr>
           <a:xfrm>
             <a:off x="640080" y="6400800"/>
-            <a:ext cx="7315200" cy="274320"/>
+            <a:ext cx="8229600" cy="274320"/>
           </a:xfrm>
           <a:prstGeom prst="rect">
             <a:avLst/>
@@ -5904,7 +9038,7 @@
       </p:sp>
       <p:sp>
         <p:nvSpPr>
-          <p:cNvPr id="6" name="Text 4"/>
+          <p:cNvPr id="7" name="Text 5"/>
           <p:cNvSpPr/>
           <p:nvPr/>
         </p:nvSpPr>

</xml_diff>